<commit_message>
feat: enhance PowerPoint generation scripts by adding no-shadow functionality for shapes and updating template files
</commit_message>
<xml_diff>
--- a/web-presentation/pdf-exports/ETRA-Presentation-Blank-Template.pptx
+++ b/web-presentation/pdf-exports/ETRA-Presentation-Blank-Template.pptx
@@ -3196,6 +3196,7 @@
           <a:ln>
             <a:noFill/>
           </a:ln>
+          <a:effectLst/>
         </p:spPr>
         <p:style>
           <a:lnRef idx="1">
@@ -3757,6 +3758,7 @@
           <a:ln>
             <a:noFill/>
           </a:ln>
+          <a:effectLst/>
         </p:spPr>
         <p:style>
           <a:lnRef idx="1">
@@ -3998,6 +4000,7 @@
           <a:ln>
             <a:noFill/>
           </a:ln>
+          <a:effectLst/>
         </p:spPr>
         <p:style>
           <a:lnRef idx="1">
@@ -4178,6 +4181,7 @@
           <a:ln>
             <a:noFill/>
           </a:ln>
+          <a:effectLst/>
         </p:spPr>
         <p:style>
           <a:lnRef idx="1">
@@ -4715,6 +4719,7 @@
           <a:ln>
             <a:noFill/>
           </a:ln>
+          <a:effectLst/>
         </p:spPr>
         <p:style>
           <a:lnRef idx="1">
@@ -4858,6 +4863,7 @@
           <a:ln>
             <a:noFill/>
           </a:ln>
+          <a:effectLst/>
         </p:spPr>
         <p:style>
           <a:lnRef idx="1">
@@ -4903,6 +4909,7 @@
           <a:ln>
             <a:noFill/>
           </a:ln>
+          <a:effectLst/>
         </p:spPr>
         <p:style>
           <a:lnRef idx="1">
@@ -5194,6 +5201,7 @@
           <a:ln>
             <a:noFill/>
           </a:ln>
+          <a:effectLst/>
         </p:spPr>
         <p:style>
           <a:lnRef idx="1">
@@ -5337,6 +5345,7 @@
           <a:ln>
             <a:noFill/>
           </a:ln>
+          <a:effectLst/>
         </p:spPr>
         <p:style>
           <a:lnRef idx="1">
@@ -5517,6 +5526,7 @@
           <a:ln>
             <a:noFill/>
           </a:ln>
+          <a:effectLst/>
         </p:spPr>
         <p:style>
           <a:lnRef idx="1">
@@ -5586,6 +5596,7 @@
           <a:ln>
             <a:noFill/>
           </a:ln>
+          <a:effectLst/>
         </p:spPr>
         <p:style>
           <a:lnRef idx="1">

</xml_diff>

<commit_message>
feat: update PowerPoint templates and scripts to align with ETRA Design System v1.0, enhancing visual consistency and usability
</commit_message>
<xml_diff>
--- a/web-presentation/pdf-exports/ETRA-Presentation-Blank-Template.pptx
+++ b/web-presentation/pdf-exports/ETRA-Presentation-Blank-Template.pptx
@@ -11,7 +11,6 @@
     <p:sldId id="259" r:id="rId10"/>
     <p:sldId id="260" r:id="rId11"/>
     <p:sldId id="261" r:id="rId12"/>
-    <p:sldId id="262" r:id="rId13"/>
   </p:sldIdLst>
   <p:sldSz cx="12191695" cy="6858000" type="screen4x3"/>
   <p:notesSz cx="6858000" cy="9144000"/>
@@ -3090,7 +3089,7 @@
     <p:bg>
       <p:bgPr>
         <a:solidFill>
-          <a:srgbClr val="FCFBFE"/>
+          <a:srgbClr val="0A0614"/>
         </a:solidFill>
         <a:effectLst/>
       </p:bgPr>
@@ -3104,94 +3103,20 @@
       <p:grpSpPr/>
       <p:sp>
         <p:nvSpPr>
-          <p:cNvPr id="2" name="TextBox 1"/>
-          <p:cNvSpPr txBox="1"/>
-          <p:nvPr/>
-        </p:nvSpPr>
-        <p:spPr>
-          <a:xfrm>
-            <a:off x="822960" y="292608"/>
-            <a:ext cx="7315200" cy="274320"/>
-          </a:xfrm>
-          <a:prstGeom prst="rect">
-            <a:avLst/>
-          </a:prstGeom>
-          <a:noFill/>
-        </p:spPr>
-        <p:txBody>
-          <a:bodyPr wrap="square">
-            <a:spAutoFit/>
-          </a:bodyPr>
-          <a:lstStyle/>
-          <a:p>
-            <a:pPr algn="l"/>
-            <a:r>
-              <a:rPr sz="1200" b="0">
-                <a:solidFill>
-                  <a:srgbClr val="7A7496"/>
-                </a:solidFill>
-                <a:latin typeface="Helvetica"/>
-                <a:ea typeface="Helvetica"/>
-                <a:cs typeface="Helvetica"/>
-              </a:rPr>
-              <a:t>Template  ·  How to use</a:t>
-            </a:r>
-          </a:p>
-        </p:txBody>
-      </p:sp>
-      <p:sp>
-        <p:nvSpPr>
-          <p:cNvPr id="3" name="TextBox 2"/>
-          <p:cNvSpPr txBox="1"/>
-          <p:nvPr/>
-        </p:nvSpPr>
-        <p:spPr>
-          <a:xfrm>
-            <a:off x="9326880" y="292608"/>
-            <a:ext cx="1280160" cy="274320"/>
-          </a:xfrm>
-          <a:prstGeom prst="rect">
-            <a:avLst/>
-          </a:prstGeom>
-          <a:noFill/>
-        </p:spPr>
-        <p:txBody>
-          <a:bodyPr wrap="square">
-            <a:spAutoFit/>
-          </a:bodyPr>
-          <a:lstStyle/>
-          <a:p>
-            <a:pPr algn="r"/>
-            <a:r>
-              <a:rPr sz="1200" b="0">
-                <a:solidFill>
-                  <a:srgbClr val="C8C0DE"/>
-                </a:solidFill>
-                <a:latin typeface="Helvetica"/>
-                <a:ea typeface="Helvetica"/>
-                <a:cs typeface="Helvetica"/>
-              </a:rPr>
-              <a:t>00</a:t>
-            </a:r>
-          </a:p>
-        </p:txBody>
-      </p:sp>
-      <p:sp>
-        <p:nvSpPr>
-          <p:cNvPr id="4" name="Rectangle 3"/>
+          <p:cNvPr id="2" name="Oval 1"/>
           <p:cNvSpPr/>
           <p:nvPr/>
         </p:nvSpPr>
         <p:spPr>
           <a:xfrm>
-            <a:off x="822960" y="658368"/>
-            <a:ext cx="10515600" cy="10972"/>
-          </a:xfrm>
-          <a:prstGeom prst="rect">
+            <a:off x="3200400" y="731520"/>
+            <a:ext cx="5943600" cy="5029200"/>
+          </a:xfrm>
+          <a:prstGeom prst="ellipse">
             <a:avLst/>
           </a:prstGeom>
           <a:solidFill>
-            <a:srgbClr val="E8E4F2"/>
+            <a:srgbClr val="2A1860"/>
           </a:solidFill>
           <a:ln>
             <a:noFill/>
@@ -3222,7 +3147,7 @@
       </p:sp>
       <p:pic>
         <p:nvPicPr>
-          <p:cNvPr id="5" name="Picture 4" descr="etra-logo.png"/>
+          <p:cNvPr id="3" name="Picture 2" descr="etra-wordmark.png"/>
           <p:cNvPicPr>
             <a:picLocks noChangeAspect="1"/>
           </p:cNvPicPr>
@@ -3236,8 +3161,8 @@
         </p:blipFill>
         <p:spPr>
           <a:xfrm>
-            <a:off x="10698480" y="320040"/>
-            <a:ext cx="546157" cy="502920"/>
+            <a:off x="10561320" y="411480"/>
+            <a:ext cx="1378516" cy="365760"/>
           </a:xfrm>
           <a:prstGeom prst="rect">
             <a:avLst/>
@@ -3246,14 +3171,14 @@
       </p:pic>
       <p:sp>
         <p:nvSpPr>
-          <p:cNvPr id="6" name="TextBox 5"/>
+          <p:cNvPr id="4" name="TextBox 3"/>
           <p:cNvSpPr txBox="1"/>
           <p:nvPr/>
         </p:nvSpPr>
         <p:spPr>
           <a:xfrm>
-            <a:off x="822960" y="960120"/>
-            <a:ext cx="10058400" cy="548640"/>
+            <a:off x="548640" y="2103120"/>
+            <a:ext cx="10058400" cy="320040"/>
           </a:xfrm>
           <a:prstGeom prst="rect">
             <a:avLst/>
@@ -3261,23 +3186,112 @@
           <a:noFill/>
         </p:spPr>
         <p:txBody>
-          <a:bodyPr wrap="square">
+          <a:bodyPr wrap="square" anchor="t">
             <a:spAutoFit/>
           </a:bodyPr>
           <a:lstStyle/>
           <a:p>
             <a:pPr algn="l"/>
             <a:r>
-              <a:rPr sz="2800" b="1">
+              <a:rPr sz="1400" b="0">
                 <a:solidFill>
-                  <a:srgbClr val="221E36"/>
+                  <a:srgbClr val="9E59CD"/>
                 </a:solidFill>
-                <a:latin typeface="Helvetica"/>
-                <a:ea typeface="Helvetica"/>
-                <a:cs typeface="Helvetica"/>
+                <a:latin typeface="DIN Next LT W23"/>
+                <a:ea typeface="DIN Next LT W23"/>
+                <a:cs typeface="DIN Next LT W23"/>
               </a:rPr>
-              <a:t>ETRA presentation template</a:t>
-            </a:r>
+              <a:t>Week X  ·  Session Y</a:t>
+            </a:r>
+          </a:p>
+        </p:txBody>
+      </p:sp>
+      <p:sp>
+        <p:nvSpPr>
+          <p:cNvPr id="5" name="TextBox 4"/>
+          <p:cNvSpPr txBox="1"/>
+          <p:nvPr/>
+        </p:nvSpPr>
+        <p:spPr>
+          <a:xfrm>
+            <a:off x="548640" y="2560320"/>
+            <a:ext cx="10515600" cy="822960"/>
+          </a:xfrm>
+          <a:prstGeom prst="rect">
+            <a:avLst/>
+          </a:prstGeom>
+          <a:noFill/>
+        </p:spPr>
+        <p:txBody>
+          <a:bodyPr wrap="square" anchor="t">
+            <a:spAutoFit/>
+          </a:bodyPr>
+          <a:lstStyle/>
+          <a:p>
+            <a:pPr algn="l"/>
+            <a:r>
+              <a:rPr sz="4400" b="1">
+                <a:solidFill>
+                  <a:srgbClr val="FFFFFF"/>
+                </a:solidFill>
+                <a:latin typeface="DIN Next LT W23"/>
+                <a:ea typeface="DIN Next LT W23"/>
+                <a:cs typeface="DIN Next LT W23"/>
+              </a:rPr>
+              <a:t>Presentation title</a:t>
+            </a:r>
+          </a:p>
+        </p:txBody>
+      </p:sp>
+      <p:sp>
+        <p:nvSpPr>
+          <p:cNvPr id="6" name="Rectangle 5"/>
+          <p:cNvSpPr/>
+          <p:nvPr/>
+        </p:nvSpPr>
+        <p:spPr>
+          <a:xfrm>
+            <a:off x="548640" y="3566160"/>
+            <a:ext cx="1280160" cy="54864"/>
+          </a:xfrm>
+          <a:prstGeom prst="rect">
+            <a:avLst/>
+          </a:prstGeom>
+          <a:gradFill rotWithShape="1">
+            <a:gsLst>
+              <a:gs pos="0">
+                <a:srgbClr val="5234B7"/>
+              </a:gs>
+              <a:gs pos="100000">
+                <a:srgbClr val="9E59CD"/>
+              </a:gs>
+            </a:gsLst>
+            <a:lin scaled="0" ang="0"/>
+          </a:gradFill>
+          <a:ln>
+            <a:noFill/>
+          </a:ln>
+          <a:effectLst/>
+        </p:spPr>
+        <p:style>
+          <a:lnRef idx="1">
+            <a:schemeClr val="accent1"/>
+          </a:lnRef>
+          <a:fillRef idx="3">
+            <a:schemeClr val="accent1"/>
+          </a:fillRef>
+          <a:effectRef idx="2">
+            <a:schemeClr val="accent1"/>
+          </a:effectRef>
+          <a:fontRef idx="minor">
+            <a:schemeClr val="lt1"/>
+          </a:fontRef>
+        </p:style>
+        <p:txBody>
+          <a:bodyPr rtlCol="0" anchor="ctr"/>
+          <a:lstStyle/>
+          <a:p>
+            <a:pPr algn="ctr"/>
           </a:p>
         </p:txBody>
       </p:sp>
@@ -3289,8 +3303,8 @@
         </p:nvSpPr>
         <p:spPr>
           <a:xfrm>
-            <a:off x="822960" y="1463040"/>
-            <a:ext cx="10058400" cy="320040"/>
+            <a:off x="548640" y="3886200"/>
+            <a:ext cx="9144000" cy="411480"/>
           </a:xfrm>
           <a:prstGeom prst="rect">
             <a:avLst/>
@@ -3298,22 +3312,22 @@
           <a:noFill/>
         </p:spPr>
         <p:txBody>
-          <a:bodyPr wrap="square">
+          <a:bodyPr wrap="square" anchor="t">
             <a:spAutoFit/>
           </a:bodyPr>
           <a:lstStyle/>
           <a:p>
             <a:pPr algn="l"/>
             <a:r>
-              <a:rPr sz="1500" b="0">
+              <a:rPr sz="1700" b="0">
                 <a:solidFill>
-                  <a:srgbClr val="7A7496"/>
+                  <a:srgbClr val="EEE8FA"/>
                 </a:solidFill>
-                <a:latin typeface="Helvetica"/>
-                <a:ea typeface="Helvetica"/>
-                <a:cs typeface="Helvetica"/>
+                <a:latin typeface="DIN Next LT W23"/>
+                <a:ea typeface="DIN Next LT W23"/>
+                <a:cs typeface="DIN Next LT W23"/>
               </a:rPr>
-              <a:t>Soft · minimal · 16:9</a:t>
+              <a:t>Subtitle — one clear line</a:t>
             </a:r>
           </a:p>
         </p:txBody>
@@ -3326,8 +3340,8 @@
         </p:nvSpPr>
         <p:spPr>
           <a:xfrm>
-            <a:off x="822960" y="2194560"/>
-            <a:ext cx="320040" cy="365760"/>
+            <a:off x="548640" y="6126480"/>
+            <a:ext cx="3657600" cy="274320"/>
           </a:xfrm>
           <a:prstGeom prst="rect">
             <a:avLst/>
@@ -3335,281 +3349,22 @@
           <a:noFill/>
         </p:spPr>
         <p:txBody>
-          <a:bodyPr wrap="square">
+          <a:bodyPr wrap="square" anchor="t">
             <a:spAutoFit/>
           </a:bodyPr>
           <a:lstStyle/>
           <a:p>
             <a:pPr algn="l"/>
             <a:r>
-              <a:rPr sz="1800" b="0">
+              <a:rPr sz="1200" b="1">
                 <a:solidFill>
-                  <a:srgbClr val="C8C0DE"/>
+                  <a:srgbClr val="9E59CD"/>
                 </a:solidFill>
-                <a:latin typeface="Helvetica"/>
-                <a:ea typeface="Helvetica"/>
-                <a:cs typeface="Helvetica"/>
+                <a:latin typeface="DIN Next LT W23"/>
+                <a:ea typeface="DIN Next LT W23"/>
+                <a:cs typeface="DIN Next LT W23"/>
               </a:rPr>
-              <a:t>–</a:t>
-            </a:r>
-          </a:p>
-        </p:txBody>
-      </p:sp>
-      <p:sp>
-        <p:nvSpPr>
-          <p:cNvPr id="9" name="TextBox 8"/>
-          <p:cNvSpPr txBox="1"/>
-          <p:nvPr/>
-        </p:nvSpPr>
-        <p:spPr>
-          <a:xfrm>
-            <a:off x="1188720" y="2194560"/>
-            <a:ext cx="10058400" cy="411480"/>
-          </a:xfrm>
-          <a:prstGeom prst="rect">
-            <a:avLst/>
-          </a:prstGeom>
-          <a:noFill/>
-        </p:spPr>
-        <p:txBody>
-          <a:bodyPr wrap="square">
-            <a:spAutoFit/>
-          </a:bodyPr>
-          <a:lstStyle/>
-          <a:p>
-            <a:pPr algn="l"/>
-            <a:r>
-              <a:rPr sz="1700" b="0">
-                <a:solidFill>
-                  <a:srgbClr val="221E36"/>
-                </a:solidFill>
-                <a:latin typeface="Helvetica"/>
-                <a:ea typeface="Helvetica"/>
-                <a:cs typeface="Helvetica"/>
-              </a:rPr>
-              <a:t>Duplicate a layout, then replace the placeholder text.</a:t>
-            </a:r>
-          </a:p>
-        </p:txBody>
-      </p:sp>
-      <p:sp>
-        <p:nvSpPr>
-          <p:cNvPr id="10" name="TextBox 9"/>
-          <p:cNvSpPr txBox="1"/>
-          <p:nvPr/>
-        </p:nvSpPr>
-        <p:spPr>
-          <a:xfrm>
-            <a:off x="822960" y="2834640"/>
-            <a:ext cx="320040" cy="365760"/>
-          </a:xfrm>
-          <a:prstGeom prst="rect">
-            <a:avLst/>
-          </a:prstGeom>
-          <a:noFill/>
-        </p:spPr>
-        <p:txBody>
-          <a:bodyPr wrap="square">
-            <a:spAutoFit/>
-          </a:bodyPr>
-          <a:lstStyle/>
-          <a:p>
-            <a:pPr algn="l"/>
-            <a:r>
-              <a:rPr sz="1800" b="0">
-                <a:solidFill>
-                  <a:srgbClr val="C8C0DE"/>
-                </a:solidFill>
-                <a:latin typeface="Helvetica"/>
-                <a:ea typeface="Helvetica"/>
-                <a:cs typeface="Helvetica"/>
-              </a:rPr>
-              <a:t>–</a:t>
-            </a:r>
-          </a:p>
-        </p:txBody>
-      </p:sp>
-      <p:sp>
-        <p:nvSpPr>
-          <p:cNvPr id="11" name="TextBox 10"/>
-          <p:cNvSpPr txBox="1"/>
-          <p:nvPr/>
-        </p:nvSpPr>
-        <p:spPr>
-          <a:xfrm>
-            <a:off x="1188720" y="2834640"/>
-            <a:ext cx="10058400" cy="411480"/>
-          </a:xfrm>
-          <a:prstGeom prst="rect">
-            <a:avLst/>
-          </a:prstGeom>
-          <a:noFill/>
-        </p:spPr>
-        <p:txBody>
-          <a:bodyPr wrap="square">
-            <a:spAutoFit/>
-          </a:bodyPr>
-          <a:lstStyle/>
-          <a:p>
-            <a:pPr algn="l"/>
-            <a:r>
-              <a:rPr sz="1700" b="0">
-                <a:solidFill>
-                  <a:srgbClr val="221E36"/>
-                </a:solidFill>
-                <a:latin typeface="Helvetica"/>
-                <a:ea typeface="Helvetica"/>
-                <a:cs typeface="Helvetica"/>
-              </a:rPr>
-              <a:t>Keep headers light — section label only.</a:t>
-            </a:r>
-          </a:p>
-        </p:txBody>
-      </p:sp>
-      <p:sp>
-        <p:nvSpPr>
-          <p:cNvPr id="12" name="TextBox 11"/>
-          <p:cNvSpPr txBox="1"/>
-          <p:nvPr/>
-        </p:nvSpPr>
-        <p:spPr>
-          <a:xfrm>
-            <a:off x="822960" y="3474720"/>
-            <a:ext cx="320040" cy="365760"/>
-          </a:xfrm>
-          <a:prstGeom prst="rect">
-            <a:avLst/>
-          </a:prstGeom>
-          <a:noFill/>
-        </p:spPr>
-        <p:txBody>
-          <a:bodyPr wrap="square">
-            <a:spAutoFit/>
-          </a:bodyPr>
-          <a:lstStyle/>
-          <a:p>
-            <a:pPr algn="l"/>
-            <a:r>
-              <a:rPr sz="1800" b="0">
-                <a:solidFill>
-                  <a:srgbClr val="C8C0DE"/>
-                </a:solidFill>
-                <a:latin typeface="Helvetica"/>
-                <a:ea typeface="Helvetica"/>
-                <a:cs typeface="Helvetica"/>
-              </a:rPr>
-              <a:t>–</a:t>
-            </a:r>
-          </a:p>
-        </p:txBody>
-      </p:sp>
-      <p:sp>
-        <p:nvSpPr>
-          <p:cNvPr id="13" name="TextBox 12"/>
-          <p:cNvSpPr txBox="1"/>
-          <p:nvPr/>
-        </p:nvSpPr>
-        <p:spPr>
-          <a:xfrm>
-            <a:off x="1188720" y="3474720"/>
-            <a:ext cx="10058400" cy="411480"/>
-          </a:xfrm>
-          <a:prstGeom prst="rect">
-            <a:avLst/>
-          </a:prstGeom>
-          <a:noFill/>
-        </p:spPr>
-        <p:txBody>
-          <a:bodyPr wrap="square">
-            <a:spAutoFit/>
-          </a:bodyPr>
-          <a:lstStyle/>
-          <a:p>
-            <a:pPr algn="l"/>
-            <a:r>
-              <a:rPr sz="1700" b="0">
-                <a:solidFill>
-                  <a:srgbClr val="221E36"/>
-                </a:solidFill>
-                <a:latin typeface="Helvetica"/>
-                <a:ea typeface="Helvetica"/>
-                <a:cs typeface="Helvetica"/>
-              </a:rPr>
-              <a:t>Use accent sparingly for current items and key words.</a:t>
-            </a:r>
-          </a:p>
-        </p:txBody>
-      </p:sp>
-      <p:sp>
-        <p:nvSpPr>
-          <p:cNvPr id="14" name="TextBox 13"/>
-          <p:cNvSpPr txBox="1"/>
-          <p:nvPr/>
-        </p:nvSpPr>
-        <p:spPr>
-          <a:xfrm>
-            <a:off x="822960" y="4114799"/>
-            <a:ext cx="320040" cy="365760"/>
-          </a:xfrm>
-          <a:prstGeom prst="rect">
-            <a:avLst/>
-          </a:prstGeom>
-          <a:noFill/>
-        </p:spPr>
-        <p:txBody>
-          <a:bodyPr wrap="square">
-            <a:spAutoFit/>
-          </a:bodyPr>
-          <a:lstStyle/>
-          <a:p>
-            <a:pPr algn="l"/>
-            <a:r>
-              <a:rPr sz="1800" b="0">
-                <a:solidFill>
-                  <a:srgbClr val="C8C0DE"/>
-                </a:solidFill>
-                <a:latin typeface="Helvetica"/>
-                <a:ea typeface="Helvetica"/>
-                <a:cs typeface="Helvetica"/>
-              </a:rPr>
-              <a:t>–</a:t>
-            </a:r>
-          </a:p>
-        </p:txBody>
-      </p:sp>
-      <p:sp>
-        <p:nvSpPr>
-          <p:cNvPr id="15" name="TextBox 14"/>
-          <p:cNvSpPr txBox="1"/>
-          <p:nvPr/>
-        </p:nvSpPr>
-        <p:spPr>
-          <a:xfrm>
-            <a:off x="1188720" y="4114799"/>
-            <a:ext cx="10058400" cy="411480"/>
-          </a:xfrm>
-          <a:prstGeom prst="rect">
-            <a:avLst/>
-          </a:prstGeom>
-          <a:noFill/>
-        </p:spPr>
-        <p:txBody>
-          <a:bodyPr wrap="square">
-            <a:spAutoFit/>
-          </a:bodyPr>
-          <a:lstStyle/>
-          <a:p>
-            <a:pPr algn="l"/>
-            <a:r>
-              <a:rPr sz="1700" b="0">
-                <a:solidFill>
-                  <a:srgbClr val="221E36"/>
-                </a:solidFill>
-                <a:latin typeface="Helvetica"/>
-                <a:ea typeface="Helvetica"/>
-                <a:cs typeface="Helvetica"/>
-              </a:rPr>
-              <a:t>Prefer short titles and calm spacing.</a:t>
+              <a:t>ETRA</a:t>
             </a:r>
           </a:p>
         </p:txBody>
@@ -3628,7 +3383,7 @@
     <p:bg>
       <p:bgPr>
         <a:solidFill>
-          <a:srgbClr val="FCFBFE"/>
+          <a:srgbClr val="FAF8FF"/>
         </a:solidFill>
         <a:effectLst/>
       </p:bgPr>
@@ -3640,120 +3395,22 @@
         <p:nvPr/>
       </p:nvGrpSpPr>
       <p:grpSpPr/>
-      <p:pic>
-        <p:nvPicPr>
-          <p:cNvPr id="2" name="Picture 1" descr="etra-logo.png"/>
-          <p:cNvPicPr>
-            <a:picLocks noChangeAspect="1"/>
-          </p:cNvPicPr>
-          <p:nvPr/>
-        </p:nvPicPr>
-        <p:blipFill>
-          <a:blip r:embed="rId2"/>
-          <a:stretch>
-            <a:fillRect/>
-          </a:stretch>
-        </p:blipFill>
-        <p:spPr>
-          <a:xfrm>
-            <a:off x="10515600" y="502920"/>
-            <a:ext cx="695110" cy="640080"/>
-          </a:xfrm>
-          <a:prstGeom prst="rect">
-            <a:avLst/>
-          </a:prstGeom>
-        </p:spPr>
-      </p:pic>
-      <p:sp>
-        <p:nvSpPr>
-          <p:cNvPr id="3" name="TextBox 2"/>
-          <p:cNvSpPr txBox="1"/>
-          <p:nvPr/>
-        </p:nvSpPr>
-        <p:spPr>
-          <a:xfrm>
-            <a:off x="822960" y="1965960"/>
-            <a:ext cx="9144000" cy="320040"/>
-          </a:xfrm>
-          <a:prstGeom prst="rect">
-            <a:avLst/>
-          </a:prstGeom>
-          <a:noFill/>
-        </p:spPr>
-        <p:txBody>
-          <a:bodyPr wrap="square">
-            <a:spAutoFit/>
-          </a:bodyPr>
-          <a:lstStyle/>
-          <a:p>
-            <a:pPr algn="l"/>
-            <a:r>
-              <a:rPr sz="1300" b="0">
-                <a:solidFill>
-                  <a:srgbClr val="7A7496"/>
-                </a:solidFill>
-                <a:latin typeface="Helvetica"/>
-                <a:ea typeface="Helvetica"/>
-                <a:cs typeface="Helvetica"/>
-              </a:rPr>
-              <a:t>Week X  ·  Session Y</a:t>
-            </a:r>
-          </a:p>
-        </p:txBody>
-      </p:sp>
-      <p:sp>
-        <p:nvSpPr>
-          <p:cNvPr id="4" name="TextBox 3"/>
-          <p:cNvSpPr txBox="1"/>
-          <p:nvPr/>
-        </p:nvSpPr>
-        <p:spPr>
-          <a:xfrm>
-            <a:off x="822960" y="2423160"/>
-            <a:ext cx="10058400" cy="822960"/>
-          </a:xfrm>
-          <a:prstGeom prst="rect">
-            <a:avLst/>
-          </a:prstGeom>
-          <a:noFill/>
-        </p:spPr>
-        <p:txBody>
-          <a:bodyPr wrap="square">
-            <a:spAutoFit/>
-          </a:bodyPr>
-          <a:lstStyle/>
-          <a:p>
-            <a:pPr algn="l"/>
-            <a:r>
-              <a:rPr sz="4400" b="1">
-                <a:solidFill>
-                  <a:srgbClr val="221E36"/>
-                </a:solidFill>
-                <a:latin typeface="Helvetica"/>
-                <a:ea typeface="Helvetica"/>
-                <a:cs typeface="Helvetica"/>
-              </a:rPr>
-              <a:t>Presentation title</a:t>
-            </a:r>
-          </a:p>
-        </p:txBody>
-      </p:sp>
-      <p:sp>
-        <p:nvSpPr>
-          <p:cNvPr id="5" name="Rectangle 4"/>
+      <p:sp>
+        <p:nvSpPr>
+          <p:cNvPr id="2" name="Rectangle 1"/>
           <p:cNvSpPr/>
           <p:nvPr/>
         </p:nvSpPr>
         <p:spPr>
           <a:xfrm>
-            <a:off x="822960" y="3383280"/>
-            <a:ext cx="1097280" cy="10972"/>
+            <a:off x="12136831" y="0"/>
+            <a:ext cx="54864" cy="6858000"/>
           </a:xfrm>
           <a:prstGeom prst="rect">
             <a:avLst/>
           </a:prstGeom>
           <a:solidFill>
-            <a:srgbClr val="E8E4F2"/>
+            <a:srgbClr val="5234B7"/>
           </a:solidFill>
           <a:ln>
             <a:noFill/>
@@ -3782,6 +3439,111 @@
           </a:p>
         </p:txBody>
       </p:sp>
+      <p:pic>
+        <p:nvPicPr>
+          <p:cNvPr id="3" name="Picture 2" descr="etra-wordmark.png"/>
+          <p:cNvPicPr>
+            <a:picLocks noChangeAspect="1"/>
+          </p:cNvPicPr>
+          <p:nvPr/>
+        </p:nvPicPr>
+        <p:blipFill>
+          <a:blip r:embed="rId2"/>
+          <a:stretch>
+            <a:fillRect/>
+          </a:stretch>
+        </p:blipFill>
+        <p:spPr>
+          <a:xfrm>
+            <a:off x="10561320" y="411480"/>
+            <a:ext cx="1206201" cy="320040"/>
+          </a:xfrm>
+          <a:prstGeom prst="rect">
+            <a:avLst/>
+          </a:prstGeom>
+        </p:spPr>
+      </p:pic>
+      <p:sp>
+        <p:nvSpPr>
+          <p:cNvPr id="4" name="TextBox 3"/>
+          <p:cNvSpPr txBox="1"/>
+          <p:nvPr/>
+        </p:nvSpPr>
+        <p:spPr>
+          <a:xfrm>
+            <a:off x="548640" y="438912"/>
+            <a:ext cx="7772400" cy="274320"/>
+          </a:xfrm>
+          <a:prstGeom prst="rect">
+            <a:avLst/>
+          </a:prstGeom>
+          <a:noFill/>
+        </p:spPr>
+        <p:txBody>
+          <a:bodyPr wrap="square" anchor="t">
+            <a:spAutoFit/>
+          </a:bodyPr>
+          <a:lstStyle/>
+          <a:p>
+            <a:pPr algn="l"/>
+            <a:r>
+              <a:rPr sz="1200" b="0">
+                <a:solidFill>
+                  <a:srgbClr val="5A5470"/>
+                </a:solidFill>
+                <a:latin typeface="DIN Next LT W23"/>
+                <a:ea typeface="DIN Next LT W23"/>
+                <a:cs typeface="DIN Next LT W23"/>
+              </a:rPr>
+              <a:t>S01  ·  Section</a:t>
+            </a:r>
+          </a:p>
+        </p:txBody>
+      </p:sp>
+      <p:sp>
+        <p:nvSpPr>
+          <p:cNvPr id="5" name="Rectangle 4"/>
+          <p:cNvSpPr/>
+          <p:nvPr/>
+        </p:nvSpPr>
+        <p:spPr>
+          <a:xfrm>
+            <a:off x="548640" y="822960"/>
+            <a:ext cx="11064240" cy="10972"/>
+          </a:xfrm>
+          <a:prstGeom prst="rect">
+            <a:avLst/>
+          </a:prstGeom>
+          <a:solidFill>
+            <a:srgbClr val="E4DCF4"/>
+          </a:solidFill>
+          <a:ln>
+            <a:noFill/>
+          </a:ln>
+          <a:effectLst/>
+        </p:spPr>
+        <p:style>
+          <a:lnRef idx="1">
+            <a:schemeClr val="accent1"/>
+          </a:lnRef>
+          <a:fillRef idx="3">
+            <a:schemeClr val="accent1"/>
+          </a:fillRef>
+          <a:effectRef idx="2">
+            <a:schemeClr val="accent1"/>
+          </a:effectRef>
+          <a:fontRef idx="minor">
+            <a:schemeClr val="lt1"/>
+          </a:fontRef>
+        </p:style>
+        <p:txBody>
+          <a:bodyPr rtlCol="0" anchor="ctr"/>
+          <a:lstStyle/>
+          <a:p>
+            <a:pPr algn="ctr"/>
+          </a:p>
+        </p:txBody>
+      </p:sp>
       <p:sp>
         <p:nvSpPr>
           <p:cNvPr id="6" name="TextBox 5"/>
@@ -3790,8 +3552,8 @@
         </p:nvSpPr>
         <p:spPr>
           <a:xfrm>
-            <a:off x="822960" y="3657600"/>
-            <a:ext cx="9144000" cy="457200"/>
+            <a:off x="548640" y="1051560"/>
+            <a:ext cx="10241280" cy="594360"/>
           </a:xfrm>
           <a:prstGeom prst="rect">
             <a:avLst/>
@@ -3799,36 +3561,110 @@
           <a:noFill/>
         </p:spPr>
         <p:txBody>
-          <a:bodyPr wrap="square">
+          <a:bodyPr wrap="square" anchor="t">
             <a:spAutoFit/>
           </a:bodyPr>
           <a:lstStyle/>
           <a:p>
             <a:pPr algn="l"/>
             <a:r>
+              <a:rPr sz="3200" b="1">
+                <a:solidFill>
+                  <a:srgbClr val="5234B7"/>
+                </a:solidFill>
+                <a:latin typeface="DIN Next LT W23"/>
+                <a:ea typeface="DIN Next LT W23"/>
+                <a:cs typeface="DIN Next LT W23"/>
+              </a:rPr>
+              <a:t>Slide title</a:t>
+            </a:r>
+          </a:p>
+        </p:txBody>
+      </p:sp>
+      <p:sp>
+        <p:nvSpPr>
+          <p:cNvPr id="7" name="TextBox 6"/>
+          <p:cNvSpPr txBox="1"/>
+          <p:nvPr/>
+        </p:nvSpPr>
+        <p:spPr>
+          <a:xfrm>
+            <a:off x="548640" y="1600200"/>
+            <a:ext cx="10241280" cy="365760"/>
+          </a:xfrm>
+          <a:prstGeom prst="rect">
+            <a:avLst/>
+          </a:prstGeom>
+          <a:noFill/>
+        </p:spPr>
+        <p:txBody>
+          <a:bodyPr wrap="square" anchor="t">
+            <a:spAutoFit/>
+          </a:bodyPr>
+          <a:lstStyle/>
+          <a:p>
+            <a:pPr algn="l"/>
+            <a:r>
+              <a:rPr sz="1500" b="0">
+                <a:solidFill>
+                  <a:srgbClr val="5A5470"/>
+                </a:solidFill>
+                <a:latin typeface="DIN Next LT W23"/>
+                <a:ea typeface="DIN Next LT W23"/>
+                <a:cs typeface="DIN Next LT W23"/>
+              </a:rPr>
+              <a:t>Optional subtitle</a:t>
+            </a:r>
+          </a:p>
+        </p:txBody>
+      </p:sp>
+      <p:sp>
+        <p:nvSpPr>
+          <p:cNvPr id="8" name="TextBox 7"/>
+          <p:cNvSpPr txBox="1"/>
+          <p:nvPr/>
+        </p:nvSpPr>
+        <p:spPr>
+          <a:xfrm>
+            <a:off x="548640" y="2148840"/>
+            <a:ext cx="320040" cy="365760"/>
+          </a:xfrm>
+          <a:prstGeom prst="rect">
+            <a:avLst/>
+          </a:prstGeom>
+          <a:noFill/>
+        </p:spPr>
+        <p:txBody>
+          <a:bodyPr wrap="square" anchor="t">
+            <a:spAutoFit/>
+          </a:bodyPr>
+          <a:lstStyle/>
+          <a:p>
+            <a:pPr algn="l"/>
+            <a:r>
               <a:rPr sz="1800" b="0">
                 <a:solidFill>
-                  <a:srgbClr val="7A7496"/>
+                  <a:srgbClr val="9E59CD"/>
                 </a:solidFill>
-                <a:latin typeface="Helvetica"/>
-                <a:ea typeface="Helvetica"/>
-                <a:cs typeface="Helvetica"/>
+                <a:latin typeface="DIN Next LT W23"/>
+                <a:ea typeface="DIN Next LT W23"/>
+                <a:cs typeface="DIN Next LT W23"/>
               </a:rPr>
-              <a:t>Subtitle — one clear line</a:t>
-            </a:r>
-          </a:p>
-        </p:txBody>
-      </p:sp>
-      <p:sp>
-        <p:nvSpPr>
-          <p:cNvPr id="7" name="TextBox 6"/>
+              <a:t>–</a:t>
+            </a:r>
+          </a:p>
+        </p:txBody>
+      </p:sp>
+      <p:sp>
+        <p:nvSpPr>
+          <p:cNvPr id="9" name="TextBox 8"/>
           <p:cNvSpPr txBox="1"/>
           <p:nvPr/>
         </p:nvSpPr>
         <p:spPr>
           <a:xfrm>
-            <a:off x="822960" y="5989320"/>
-            <a:ext cx="9144000" cy="320040"/>
+            <a:off x="914400" y="2148840"/>
+            <a:ext cx="10058400" cy="411480"/>
           </a:xfrm>
           <a:prstGeom prst="rect">
             <a:avLst/>
@@ -3836,22 +3672,362 @@
           <a:noFill/>
         </p:spPr>
         <p:txBody>
-          <a:bodyPr wrap="square">
+          <a:bodyPr wrap="square" anchor="t">
             <a:spAutoFit/>
           </a:bodyPr>
           <a:lstStyle/>
           <a:p>
             <a:pPr algn="l"/>
             <a:r>
-              <a:rPr sz="1300" b="0">
+              <a:rPr sz="1800" b="0">
                 <a:solidFill>
-                  <a:srgbClr val="C8C0DE"/>
+                  <a:srgbClr val="121018"/>
                 </a:solidFill>
-                <a:latin typeface="Helvetica"/>
-                <a:ea typeface="Helvetica"/>
-                <a:cs typeface="Helvetica"/>
+                <a:latin typeface="DIN Next LT W23"/>
+                <a:ea typeface="DIN Next LT W23"/>
+                <a:cs typeface="DIN Next LT W23"/>
               </a:rPr>
-              <a:t>Trainer  ·  Date  ·  Organization</a:t>
+              <a:t>First point</a:t>
+            </a:r>
+          </a:p>
+        </p:txBody>
+      </p:sp>
+      <p:sp>
+        <p:nvSpPr>
+          <p:cNvPr id="10" name="TextBox 9"/>
+          <p:cNvSpPr txBox="1"/>
+          <p:nvPr/>
+        </p:nvSpPr>
+        <p:spPr>
+          <a:xfrm>
+            <a:off x="548640" y="2770632"/>
+            <a:ext cx="320040" cy="365760"/>
+          </a:xfrm>
+          <a:prstGeom prst="rect">
+            <a:avLst/>
+          </a:prstGeom>
+          <a:noFill/>
+        </p:spPr>
+        <p:txBody>
+          <a:bodyPr wrap="square" anchor="t">
+            <a:spAutoFit/>
+          </a:bodyPr>
+          <a:lstStyle/>
+          <a:p>
+            <a:pPr algn="l"/>
+            <a:r>
+              <a:rPr sz="1800" b="0">
+                <a:solidFill>
+                  <a:srgbClr val="9E59CD"/>
+                </a:solidFill>
+                <a:latin typeface="DIN Next LT W23"/>
+                <a:ea typeface="DIN Next LT W23"/>
+                <a:cs typeface="DIN Next LT W23"/>
+              </a:rPr>
+              <a:t>–</a:t>
+            </a:r>
+          </a:p>
+        </p:txBody>
+      </p:sp>
+      <p:sp>
+        <p:nvSpPr>
+          <p:cNvPr id="11" name="TextBox 10"/>
+          <p:cNvSpPr txBox="1"/>
+          <p:nvPr/>
+        </p:nvSpPr>
+        <p:spPr>
+          <a:xfrm>
+            <a:off x="914400" y="2770632"/>
+            <a:ext cx="10058400" cy="411480"/>
+          </a:xfrm>
+          <a:prstGeom prst="rect">
+            <a:avLst/>
+          </a:prstGeom>
+          <a:noFill/>
+        </p:spPr>
+        <p:txBody>
+          <a:bodyPr wrap="square" anchor="t">
+            <a:spAutoFit/>
+          </a:bodyPr>
+          <a:lstStyle/>
+          <a:p>
+            <a:pPr algn="l"/>
+            <a:r>
+              <a:rPr sz="1800" b="0">
+                <a:solidFill>
+                  <a:srgbClr val="121018"/>
+                </a:solidFill>
+                <a:latin typeface="DIN Next LT W23"/>
+                <a:ea typeface="DIN Next LT W23"/>
+                <a:cs typeface="DIN Next LT W23"/>
+              </a:rPr>
+              <a:t>Second point</a:t>
+            </a:r>
+          </a:p>
+        </p:txBody>
+      </p:sp>
+      <p:sp>
+        <p:nvSpPr>
+          <p:cNvPr id="12" name="TextBox 11"/>
+          <p:cNvSpPr txBox="1"/>
+          <p:nvPr/>
+        </p:nvSpPr>
+        <p:spPr>
+          <a:xfrm>
+            <a:off x="548640" y="3392424"/>
+            <a:ext cx="320040" cy="365760"/>
+          </a:xfrm>
+          <a:prstGeom prst="rect">
+            <a:avLst/>
+          </a:prstGeom>
+          <a:noFill/>
+        </p:spPr>
+        <p:txBody>
+          <a:bodyPr wrap="square" anchor="t">
+            <a:spAutoFit/>
+          </a:bodyPr>
+          <a:lstStyle/>
+          <a:p>
+            <a:pPr algn="l"/>
+            <a:r>
+              <a:rPr sz="1800" b="0">
+                <a:solidFill>
+                  <a:srgbClr val="9E59CD"/>
+                </a:solidFill>
+                <a:latin typeface="DIN Next LT W23"/>
+                <a:ea typeface="DIN Next LT W23"/>
+                <a:cs typeface="DIN Next LT W23"/>
+              </a:rPr>
+              <a:t>–</a:t>
+            </a:r>
+          </a:p>
+        </p:txBody>
+      </p:sp>
+      <p:sp>
+        <p:nvSpPr>
+          <p:cNvPr id="13" name="TextBox 12"/>
+          <p:cNvSpPr txBox="1"/>
+          <p:nvPr/>
+        </p:nvSpPr>
+        <p:spPr>
+          <a:xfrm>
+            <a:off x="914400" y="3392424"/>
+            <a:ext cx="10058400" cy="411480"/>
+          </a:xfrm>
+          <a:prstGeom prst="rect">
+            <a:avLst/>
+          </a:prstGeom>
+          <a:noFill/>
+        </p:spPr>
+        <p:txBody>
+          <a:bodyPr wrap="square" anchor="t">
+            <a:spAutoFit/>
+          </a:bodyPr>
+          <a:lstStyle/>
+          <a:p>
+            <a:pPr algn="l"/>
+            <a:r>
+              <a:rPr sz="1800" b="0">
+                <a:solidFill>
+                  <a:srgbClr val="121018"/>
+                </a:solidFill>
+                <a:latin typeface="DIN Next LT W23"/>
+                <a:ea typeface="DIN Next LT W23"/>
+                <a:cs typeface="DIN Next LT W23"/>
+              </a:rPr>
+              <a:t>Third point</a:t>
+            </a:r>
+          </a:p>
+        </p:txBody>
+      </p:sp>
+      <p:sp>
+        <p:nvSpPr>
+          <p:cNvPr id="14" name="TextBox 13"/>
+          <p:cNvSpPr txBox="1"/>
+          <p:nvPr/>
+        </p:nvSpPr>
+        <p:spPr>
+          <a:xfrm>
+            <a:off x="548640" y="4014216"/>
+            <a:ext cx="320040" cy="365760"/>
+          </a:xfrm>
+          <a:prstGeom prst="rect">
+            <a:avLst/>
+          </a:prstGeom>
+          <a:noFill/>
+        </p:spPr>
+        <p:txBody>
+          <a:bodyPr wrap="square" anchor="t">
+            <a:spAutoFit/>
+          </a:bodyPr>
+          <a:lstStyle/>
+          <a:p>
+            <a:pPr algn="l"/>
+            <a:r>
+              <a:rPr sz="1800" b="0">
+                <a:solidFill>
+                  <a:srgbClr val="9E59CD"/>
+                </a:solidFill>
+                <a:latin typeface="DIN Next LT W23"/>
+                <a:ea typeface="DIN Next LT W23"/>
+                <a:cs typeface="DIN Next LT W23"/>
+              </a:rPr>
+              <a:t>–</a:t>
+            </a:r>
+          </a:p>
+        </p:txBody>
+      </p:sp>
+      <p:sp>
+        <p:nvSpPr>
+          <p:cNvPr id="15" name="TextBox 14"/>
+          <p:cNvSpPr txBox="1"/>
+          <p:nvPr/>
+        </p:nvSpPr>
+        <p:spPr>
+          <a:xfrm>
+            <a:off x="914400" y="4014216"/>
+            <a:ext cx="10058400" cy="411480"/>
+          </a:xfrm>
+          <a:prstGeom prst="rect">
+            <a:avLst/>
+          </a:prstGeom>
+          <a:noFill/>
+        </p:spPr>
+        <p:txBody>
+          <a:bodyPr wrap="square" anchor="t">
+            <a:spAutoFit/>
+          </a:bodyPr>
+          <a:lstStyle/>
+          <a:p>
+            <a:pPr algn="l"/>
+            <a:r>
+              <a:rPr sz="1800" b="0">
+                <a:solidFill>
+                  <a:srgbClr val="121018"/>
+                </a:solidFill>
+                <a:latin typeface="DIN Next LT W23"/>
+                <a:ea typeface="DIN Next LT W23"/>
+                <a:cs typeface="DIN Next LT W23"/>
+              </a:rPr>
+              <a:t>Fourth point</a:t>
+            </a:r>
+          </a:p>
+        </p:txBody>
+      </p:sp>
+      <p:sp>
+        <p:nvSpPr>
+          <p:cNvPr id="16" name="Rectangle 15"/>
+          <p:cNvSpPr/>
+          <p:nvPr/>
+        </p:nvSpPr>
+        <p:spPr>
+          <a:xfrm>
+            <a:off x="548640" y="6446520"/>
+            <a:ext cx="11064240" cy="10972"/>
+          </a:xfrm>
+          <a:prstGeom prst="rect">
+            <a:avLst/>
+          </a:prstGeom>
+          <a:solidFill>
+            <a:srgbClr val="5234B7"/>
+          </a:solidFill>
+          <a:ln>
+            <a:noFill/>
+          </a:ln>
+          <a:effectLst/>
+        </p:spPr>
+        <p:style>
+          <a:lnRef idx="1">
+            <a:schemeClr val="accent1"/>
+          </a:lnRef>
+          <a:fillRef idx="3">
+            <a:schemeClr val="accent1"/>
+          </a:fillRef>
+          <a:effectRef idx="2">
+            <a:schemeClr val="accent1"/>
+          </a:effectRef>
+          <a:fontRef idx="minor">
+            <a:schemeClr val="lt1"/>
+          </a:fontRef>
+        </p:style>
+        <p:txBody>
+          <a:bodyPr rtlCol="0" anchor="ctr"/>
+          <a:lstStyle/>
+          <a:p>
+            <a:pPr algn="ctr"/>
+          </a:p>
+        </p:txBody>
+      </p:sp>
+      <p:sp>
+        <p:nvSpPr>
+          <p:cNvPr id="17" name="TextBox 16"/>
+          <p:cNvSpPr txBox="1"/>
+          <p:nvPr/>
+        </p:nvSpPr>
+        <p:spPr>
+          <a:xfrm>
+            <a:off x="548640" y="6510528"/>
+            <a:ext cx="2743200" cy="256032"/>
+          </a:xfrm>
+          <a:prstGeom prst="rect">
+            <a:avLst/>
+          </a:prstGeom>
+          <a:noFill/>
+        </p:spPr>
+        <p:txBody>
+          <a:bodyPr wrap="square" anchor="t">
+            <a:spAutoFit/>
+          </a:bodyPr>
+          <a:lstStyle/>
+          <a:p>
+            <a:pPr algn="l"/>
+            <a:r>
+              <a:rPr sz="1100" b="1">
+                <a:solidFill>
+                  <a:srgbClr val="5234B7"/>
+                </a:solidFill>
+                <a:latin typeface="DIN Next LT W23"/>
+                <a:ea typeface="DIN Next LT W23"/>
+                <a:cs typeface="DIN Next LT W23"/>
+              </a:rPr>
+              <a:t>ETRA</a:t>
+            </a:r>
+          </a:p>
+        </p:txBody>
+      </p:sp>
+      <p:sp>
+        <p:nvSpPr>
+          <p:cNvPr id="18" name="TextBox 17"/>
+          <p:cNvSpPr txBox="1"/>
+          <p:nvPr/>
+        </p:nvSpPr>
+        <p:spPr>
+          <a:xfrm>
+            <a:off x="9601200" y="6510528"/>
+            <a:ext cx="2011680" cy="256032"/>
+          </a:xfrm>
+          <a:prstGeom prst="rect">
+            <a:avLst/>
+          </a:prstGeom>
+          <a:noFill/>
+        </p:spPr>
+        <p:txBody>
+          <a:bodyPr wrap="square" anchor="t">
+            <a:spAutoFit/>
+          </a:bodyPr>
+          <a:lstStyle/>
+          <a:p>
+            <a:pPr algn="r"/>
+            <a:r>
+              <a:rPr sz="1100" b="0">
+                <a:solidFill>
+                  <a:srgbClr val="5A5470"/>
+                </a:solidFill>
+                <a:latin typeface="DIN Next LT W23"/>
+                <a:ea typeface="DIN Next LT W23"/>
+                <a:cs typeface="DIN Next LT W23"/>
+              </a:rPr>
+              <a:t>02  /  06</a:t>
             </a:r>
           </a:p>
         </p:txBody>
@@ -3870,7 +4046,7 @@
     <p:bg>
       <p:bgPr>
         <a:solidFill>
-          <a:srgbClr val="FCFBFE"/>
+          <a:srgbClr val="FAF8FF"/>
         </a:solidFill>
         <a:effectLst/>
       </p:bgPr>
@@ -3882,120 +4058,22 @@
         <p:nvPr/>
       </p:nvGrpSpPr>
       <p:grpSpPr/>
-      <p:pic>
-        <p:nvPicPr>
-          <p:cNvPr id="2" name="Picture 1" descr="etra-logo.png"/>
-          <p:cNvPicPr>
-            <a:picLocks noChangeAspect="1"/>
-          </p:cNvPicPr>
-          <p:nvPr/>
-        </p:nvPicPr>
-        <p:blipFill>
-          <a:blip r:embed="rId2"/>
-          <a:stretch>
-            <a:fillRect/>
-          </a:stretch>
-        </p:blipFill>
-        <p:spPr>
-          <a:xfrm>
-            <a:off x="10515600" y="502920"/>
-            <a:ext cx="645459" cy="594360"/>
-          </a:xfrm>
-          <a:prstGeom prst="rect">
-            <a:avLst/>
-          </a:prstGeom>
-        </p:spPr>
-      </p:pic>
-      <p:sp>
-        <p:nvSpPr>
-          <p:cNvPr id="3" name="TextBox 2"/>
-          <p:cNvSpPr txBox="1"/>
-          <p:nvPr/>
-        </p:nvSpPr>
-        <p:spPr>
-          <a:xfrm>
-            <a:off x="822960" y="1828800"/>
-            <a:ext cx="9144000" cy="320040"/>
-          </a:xfrm>
-          <a:prstGeom prst="rect">
-            <a:avLst/>
-          </a:prstGeom>
-          <a:noFill/>
-        </p:spPr>
-        <p:txBody>
-          <a:bodyPr wrap="square">
-            <a:spAutoFit/>
-          </a:bodyPr>
-          <a:lstStyle/>
-          <a:p>
-            <a:pPr algn="l"/>
-            <a:r>
-              <a:rPr sz="1300" b="0">
-                <a:solidFill>
-                  <a:srgbClr val="7A7496"/>
-                </a:solidFill>
-                <a:latin typeface="Helvetica"/>
-                <a:ea typeface="Helvetica"/>
-                <a:cs typeface="Helvetica"/>
-              </a:rPr>
-              <a:t>Week X  ·  Session Y</a:t>
-            </a:r>
-          </a:p>
-        </p:txBody>
-      </p:sp>
-      <p:sp>
-        <p:nvSpPr>
-          <p:cNvPr id="4" name="TextBox 3"/>
-          <p:cNvSpPr txBox="1"/>
-          <p:nvPr/>
-        </p:nvSpPr>
-        <p:spPr>
-          <a:xfrm>
-            <a:off x="822960" y="2286000"/>
-            <a:ext cx="10058400" cy="777240"/>
-          </a:xfrm>
-          <a:prstGeom prst="rect">
-            <a:avLst/>
-          </a:prstGeom>
-          <a:noFill/>
-        </p:spPr>
-        <p:txBody>
-          <a:bodyPr wrap="square">
-            <a:spAutoFit/>
-          </a:bodyPr>
-          <a:lstStyle/>
-          <a:p>
-            <a:pPr algn="l"/>
-            <a:r>
-              <a:rPr sz="4000" b="1">
-                <a:solidFill>
-                  <a:srgbClr val="221E36"/>
-                </a:solidFill>
-                <a:latin typeface="Helvetica"/>
-                <a:ea typeface="Helvetica"/>
-                <a:cs typeface="Helvetica"/>
-              </a:rPr>
-              <a:t>Section title</a:t>
-            </a:r>
-          </a:p>
-        </p:txBody>
-      </p:sp>
-      <p:sp>
-        <p:nvSpPr>
-          <p:cNvPr id="5" name="Rectangle 4"/>
+      <p:sp>
+        <p:nvSpPr>
+          <p:cNvPr id="2" name="Rectangle 1"/>
           <p:cNvSpPr/>
           <p:nvPr/>
         </p:nvSpPr>
         <p:spPr>
           <a:xfrm>
-            <a:off x="822960" y="3200400"/>
-            <a:ext cx="1097280" cy="10972"/>
+            <a:off x="12136831" y="0"/>
+            <a:ext cx="54864" cy="6858000"/>
           </a:xfrm>
           <a:prstGeom prst="rect">
             <a:avLst/>
           </a:prstGeom>
           <a:solidFill>
-            <a:srgbClr val="E8E4F2"/>
+            <a:srgbClr val="5234B7"/>
           </a:solidFill>
           <a:ln>
             <a:noFill/>
@@ -4024,6 +4102,111 @@
           </a:p>
         </p:txBody>
       </p:sp>
+      <p:pic>
+        <p:nvPicPr>
+          <p:cNvPr id="3" name="Picture 2" descr="etra-wordmark.png"/>
+          <p:cNvPicPr>
+            <a:picLocks noChangeAspect="1"/>
+          </p:cNvPicPr>
+          <p:nvPr/>
+        </p:nvPicPr>
+        <p:blipFill>
+          <a:blip r:embed="rId2"/>
+          <a:stretch>
+            <a:fillRect/>
+          </a:stretch>
+        </p:blipFill>
+        <p:spPr>
+          <a:xfrm>
+            <a:off x="10561320" y="411480"/>
+            <a:ext cx="1206201" cy="320040"/>
+          </a:xfrm>
+          <a:prstGeom prst="rect">
+            <a:avLst/>
+          </a:prstGeom>
+        </p:spPr>
+      </p:pic>
+      <p:sp>
+        <p:nvSpPr>
+          <p:cNvPr id="4" name="TextBox 3"/>
+          <p:cNvSpPr txBox="1"/>
+          <p:nvPr/>
+        </p:nvSpPr>
+        <p:spPr>
+          <a:xfrm>
+            <a:off x="548640" y="438912"/>
+            <a:ext cx="7772400" cy="274320"/>
+          </a:xfrm>
+          <a:prstGeom prst="rect">
+            <a:avLst/>
+          </a:prstGeom>
+          <a:noFill/>
+        </p:spPr>
+        <p:txBody>
+          <a:bodyPr wrap="square" anchor="t">
+            <a:spAutoFit/>
+          </a:bodyPr>
+          <a:lstStyle/>
+          <a:p>
+            <a:pPr algn="l"/>
+            <a:r>
+              <a:rPr sz="1200" b="0">
+                <a:solidFill>
+                  <a:srgbClr val="5A5470"/>
+                </a:solidFill>
+                <a:latin typeface="DIN Next LT W23"/>
+                <a:ea typeface="DIN Next LT W23"/>
+                <a:cs typeface="DIN Next LT W23"/>
+              </a:rPr>
+              <a:t>S01  ·  Section</a:t>
+            </a:r>
+          </a:p>
+        </p:txBody>
+      </p:sp>
+      <p:sp>
+        <p:nvSpPr>
+          <p:cNvPr id="5" name="Rectangle 4"/>
+          <p:cNvSpPr/>
+          <p:nvPr/>
+        </p:nvSpPr>
+        <p:spPr>
+          <a:xfrm>
+            <a:off x="548640" y="822960"/>
+            <a:ext cx="11064240" cy="10972"/>
+          </a:xfrm>
+          <a:prstGeom prst="rect">
+            <a:avLst/>
+          </a:prstGeom>
+          <a:solidFill>
+            <a:srgbClr val="E4DCF4"/>
+          </a:solidFill>
+          <a:ln>
+            <a:noFill/>
+          </a:ln>
+          <a:effectLst/>
+        </p:spPr>
+        <p:style>
+          <a:lnRef idx="1">
+            <a:schemeClr val="accent1"/>
+          </a:lnRef>
+          <a:fillRef idx="3">
+            <a:schemeClr val="accent1"/>
+          </a:fillRef>
+          <a:effectRef idx="2">
+            <a:schemeClr val="accent1"/>
+          </a:effectRef>
+          <a:fontRef idx="minor">
+            <a:schemeClr val="lt1"/>
+          </a:fontRef>
+        </p:style>
+        <p:txBody>
+          <a:bodyPr rtlCol="0" anchor="ctr"/>
+          <a:lstStyle/>
+          <a:p>
+            <a:pPr algn="ctr"/>
+          </a:p>
+        </p:txBody>
+      </p:sp>
       <p:sp>
         <p:nvSpPr>
           <p:cNvPr id="6" name="TextBox 5"/>
@@ -4032,8 +4215,8 @@
         </p:nvSpPr>
         <p:spPr>
           <a:xfrm>
-            <a:off x="822960" y="3474720"/>
-            <a:ext cx="9144000" cy="365760"/>
+            <a:off x="548640" y="1051560"/>
+            <a:ext cx="10241280" cy="594360"/>
           </a:xfrm>
           <a:prstGeom prst="rect">
             <a:avLst/>
@@ -4041,22 +4224,306 @@
           <a:noFill/>
         </p:spPr>
         <p:txBody>
-          <a:bodyPr wrap="square">
+          <a:bodyPr wrap="square" anchor="t">
             <a:spAutoFit/>
           </a:bodyPr>
           <a:lstStyle/>
           <a:p>
             <a:pPr algn="l"/>
             <a:r>
-              <a:rPr sz="1600" b="0">
+              <a:rPr sz="3200" b="1">
                 <a:solidFill>
-                  <a:srgbClr val="7A7496"/>
+                  <a:srgbClr val="5234B7"/>
                 </a:solidFill>
-                <a:latin typeface="Helvetica"/>
-                <a:ea typeface="Helvetica"/>
-                <a:cs typeface="Helvetica"/>
+                <a:latin typeface="DIN Next LT W23"/>
+                <a:ea typeface="DIN Next LT W23"/>
+                <a:cs typeface="DIN Next LT W23"/>
               </a:rPr>
-              <a:t>Short focus line for this section</a:t>
+              <a:t>Compare / two columns</a:t>
+            </a:r>
+          </a:p>
+        </p:txBody>
+      </p:sp>
+      <p:sp>
+        <p:nvSpPr>
+          <p:cNvPr id="7" name="Rounded Rectangle 6"/>
+          <p:cNvSpPr/>
+          <p:nvPr/>
+        </p:nvSpPr>
+        <p:spPr>
+          <a:xfrm>
+            <a:off x="548640" y="2103120"/>
+            <a:ext cx="5212080" cy="3657600"/>
+          </a:xfrm>
+          <a:prstGeom prst="roundRect">
+            <a:avLst>
+              <a:gd name="adj" fmla="val 10000"/>
+            </a:avLst>
+          </a:prstGeom>
+          <a:solidFill>
+            <a:srgbClr val="EEE8FA"/>
+          </a:solidFill>
+          <a:ln>
+            <a:noFill/>
+          </a:ln>
+          <a:effectLst/>
+        </p:spPr>
+        <p:style>
+          <a:lnRef idx="1">
+            <a:schemeClr val="accent1"/>
+          </a:lnRef>
+          <a:fillRef idx="3">
+            <a:schemeClr val="accent1"/>
+          </a:fillRef>
+          <a:effectRef idx="2">
+            <a:schemeClr val="accent1"/>
+          </a:effectRef>
+          <a:fontRef idx="minor">
+            <a:schemeClr val="lt1"/>
+          </a:fontRef>
+        </p:style>
+        <p:txBody>
+          <a:bodyPr rtlCol="0" anchor="ctr"/>
+          <a:lstStyle/>
+          <a:p>
+            <a:pPr algn="ctr"/>
+          </a:p>
+        </p:txBody>
+      </p:sp>
+      <p:sp>
+        <p:nvSpPr>
+          <p:cNvPr id="8" name="Rounded Rectangle 7"/>
+          <p:cNvSpPr/>
+          <p:nvPr/>
+        </p:nvSpPr>
+        <p:spPr>
+          <a:xfrm>
+            <a:off x="6400800" y="2103120"/>
+            <a:ext cx="5212080" cy="3657600"/>
+          </a:xfrm>
+          <a:prstGeom prst="roundRect">
+            <a:avLst>
+              <a:gd name="adj" fmla="val 10000"/>
+            </a:avLst>
+          </a:prstGeom>
+          <a:solidFill>
+            <a:srgbClr val="EEE8FA"/>
+          </a:solidFill>
+          <a:ln>
+            <a:noFill/>
+          </a:ln>
+          <a:effectLst/>
+        </p:spPr>
+        <p:style>
+          <a:lnRef idx="1">
+            <a:schemeClr val="accent1"/>
+          </a:lnRef>
+          <a:fillRef idx="3">
+            <a:schemeClr val="accent1"/>
+          </a:fillRef>
+          <a:effectRef idx="2">
+            <a:schemeClr val="accent1"/>
+          </a:effectRef>
+          <a:fontRef idx="minor">
+            <a:schemeClr val="lt1"/>
+          </a:fontRef>
+        </p:style>
+        <p:txBody>
+          <a:bodyPr rtlCol="0" anchor="ctr"/>
+          <a:lstStyle/>
+          <a:p>
+            <a:pPr algn="ctr"/>
+          </a:p>
+        </p:txBody>
+      </p:sp>
+      <p:sp>
+        <p:nvSpPr>
+          <p:cNvPr id="9" name="TextBox 8"/>
+          <p:cNvSpPr txBox="1"/>
+          <p:nvPr/>
+        </p:nvSpPr>
+        <p:spPr>
+          <a:xfrm>
+            <a:off x="868680" y="2377440"/>
+            <a:ext cx="4572000" cy="365760"/>
+          </a:xfrm>
+          <a:prstGeom prst="rect">
+            <a:avLst/>
+          </a:prstGeom>
+          <a:noFill/>
+        </p:spPr>
+        <p:txBody>
+          <a:bodyPr wrap="square" anchor="t">
+            <a:spAutoFit/>
+          </a:bodyPr>
+          <a:lstStyle/>
+          <a:p>
+            <a:pPr algn="l"/>
+            <a:r>
+              <a:rPr sz="1600" b="1">
+                <a:solidFill>
+                  <a:srgbClr val="5234B7"/>
+                </a:solidFill>
+                <a:latin typeface="DIN Next LT W23"/>
+                <a:ea typeface="DIN Next LT W23"/>
+                <a:cs typeface="DIN Next LT W23"/>
+              </a:rPr>
+              <a:t>Left</a:t>
+            </a:r>
+          </a:p>
+        </p:txBody>
+      </p:sp>
+      <p:sp>
+        <p:nvSpPr>
+          <p:cNvPr id="10" name="TextBox 9"/>
+          <p:cNvSpPr txBox="1"/>
+          <p:nvPr/>
+        </p:nvSpPr>
+        <p:spPr>
+          <a:xfrm>
+            <a:off x="6720840" y="2377440"/>
+            <a:ext cx="4572000" cy="365760"/>
+          </a:xfrm>
+          <a:prstGeom prst="rect">
+            <a:avLst/>
+          </a:prstGeom>
+          <a:noFill/>
+        </p:spPr>
+        <p:txBody>
+          <a:bodyPr wrap="square" anchor="t">
+            <a:spAutoFit/>
+          </a:bodyPr>
+          <a:lstStyle/>
+          <a:p>
+            <a:pPr algn="l"/>
+            <a:r>
+              <a:rPr sz="1600" b="1">
+                <a:solidFill>
+                  <a:srgbClr val="5234B7"/>
+                </a:solidFill>
+                <a:latin typeface="DIN Next LT W23"/>
+                <a:ea typeface="DIN Next LT W23"/>
+                <a:cs typeface="DIN Next LT W23"/>
+              </a:rPr>
+              <a:t>Right</a:t>
+            </a:r>
+          </a:p>
+        </p:txBody>
+      </p:sp>
+      <p:sp>
+        <p:nvSpPr>
+          <p:cNvPr id="11" name="Rectangle 10"/>
+          <p:cNvSpPr/>
+          <p:nvPr/>
+        </p:nvSpPr>
+        <p:spPr>
+          <a:xfrm>
+            <a:off x="548640" y="6446520"/>
+            <a:ext cx="11064240" cy="10972"/>
+          </a:xfrm>
+          <a:prstGeom prst="rect">
+            <a:avLst/>
+          </a:prstGeom>
+          <a:solidFill>
+            <a:srgbClr val="5234B7"/>
+          </a:solidFill>
+          <a:ln>
+            <a:noFill/>
+          </a:ln>
+          <a:effectLst/>
+        </p:spPr>
+        <p:style>
+          <a:lnRef idx="1">
+            <a:schemeClr val="accent1"/>
+          </a:lnRef>
+          <a:fillRef idx="3">
+            <a:schemeClr val="accent1"/>
+          </a:fillRef>
+          <a:effectRef idx="2">
+            <a:schemeClr val="accent1"/>
+          </a:effectRef>
+          <a:fontRef idx="minor">
+            <a:schemeClr val="lt1"/>
+          </a:fontRef>
+        </p:style>
+        <p:txBody>
+          <a:bodyPr rtlCol="0" anchor="ctr"/>
+          <a:lstStyle/>
+          <a:p>
+            <a:pPr algn="ctr"/>
+          </a:p>
+        </p:txBody>
+      </p:sp>
+      <p:sp>
+        <p:nvSpPr>
+          <p:cNvPr id="12" name="TextBox 11"/>
+          <p:cNvSpPr txBox="1"/>
+          <p:nvPr/>
+        </p:nvSpPr>
+        <p:spPr>
+          <a:xfrm>
+            <a:off x="548640" y="6510528"/>
+            <a:ext cx="2743200" cy="256032"/>
+          </a:xfrm>
+          <a:prstGeom prst="rect">
+            <a:avLst/>
+          </a:prstGeom>
+          <a:noFill/>
+        </p:spPr>
+        <p:txBody>
+          <a:bodyPr wrap="square" anchor="t">
+            <a:spAutoFit/>
+          </a:bodyPr>
+          <a:lstStyle/>
+          <a:p>
+            <a:pPr algn="l"/>
+            <a:r>
+              <a:rPr sz="1100" b="1">
+                <a:solidFill>
+                  <a:srgbClr val="5234B7"/>
+                </a:solidFill>
+                <a:latin typeface="DIN Next LT W23"/>
+                <a:ea typeface="DIN Next LT W23"/>
+                <a:cs typeface="DIN Next LT W23"/>
+              </a:rPr>
+              <a:t>ETRA</a:t>
+            </a:r>
+          </a:p>
+        </p:txBody>
+      </p:sp>
+      <p:sp>
+        <p:nvSpPr>
+          <p:cNvPr id="13" name="TextBox 12"/>
+          <p:cNvSpPr txBox="1"/>
+          <p:nvPr/>
+        </p:nvSpPr>
+        <p:spPr>
+          <a:xfrm>
+            <a:off x="9601200" y="6510528"/>
+            <a:ext cx="2011680" cy="256032"/>
+          </a:xfrm>
+          <a:prstGeom prst="rect">
+            <a:avLst/>
+          </a:prstGeom>
+          <a:noFill/>
+        </p:spPr>
+        <p:txBody>
+          <a:bodyPr wrap="square" anchor="t">
+            <a:spAutoFit/>
+          </a:bodyPr>
+          <a:lstStyle/>
+          <a:p>
+            <a:pPr algn="r"/>
+            <a:r>
+              <a:rPr sz="1100" b="0">
+                <a:solidFill>
+                  <a:srgbClr val="5A5470"/>
+                </a:solidFill>
+                <a:latin typeface="DIN Next LT W23"/>
+                <a:ea typeface="DIN Next LT W23"/>
+                <a:cs typeface="DIN Next LT W23"/>
+              </a:rPr>
+              <a:t>03  /  06</a:t>
             </a:r>
           </a:p>
         </p:txBody>
@@ -4075,7 +4542,7 @@
     <p:bg>
       <p:bgPr>
         <a:solidFill>
-          <a:srgbClr val="FCFBFE"/>
+          <a:srgbClr val="FAF8FF"/>
         </a:solidFill>
         <a:effectLst/>
       </p:bgPr>
@@ -4089,94 +4556,20 @@
       <p:grpSpPr/>
       <p:sp>
         <p:nvSpPr>
-          <p:cNvPr id="2" name="TextBox 1"/>
-          <p:cNvSpPr txBox="1"/>
-          <p:nvPr/>
-        </p:nvSpPr>
-        <p:spPr>
-          <a:xfrm>
-            <a:off x="822960" y="292608"/>
-            <a:ext cx="7315200" cy="274320"/>
-          </a:xfrm>
-          <a:prstGeom prst="rect">
-            <a:avLst/>
-          </a:prstGeom>
-          <a:noFill/>
-        </p:spPr>
-        <p:txBody>
-          <a:bodyPr wrap="square">
-            <a:spAutoFit/>
-          </a:bodyPr>
-          <a:lstStyle/>
-          <a:p>
-            <a:pPr algn="l"/>
-            <a:r>
-              <a:rPr sz="1200" b="0">
-                <a:solidFill>
-                  <a:srgbClr val="7A7496"/>
-                </a:solidFill>
-                <a:latin typeface="Helvetica"/>
-                <a:ea typeface="Helvetica"/>
-                <a:cs typeface="Helvetica"/>
-              </a:rPr>
-              <a:t>Section  ·  Topic</a:t>
-            </a:r>
-          </a:p>
-        </p:txBody>
-      </p:sp>
-      <p:sp>
-        <p:nvSpPr>
-          <p:cNvPr id="3" name="TextBox 2"/>
-          <p:cNvSpPr txBox="1"/>
-          <p:nvPr/>
-        </p:nvSpPr>
-        <p:spPr>
-          <a:xfrm>
-            <a:off x="9326880" y="292608"/>
-            <a:ext cx="1280160" cy="274320"/>
-          </a:xfrm>
-          <a:prstGeom prst="rect">
-            <a:avLst/>
-          </a:prstGeom>
-          <a:noFill/>
-        </p:spPr>
-        <p:txBody>
-          <a:bodyPr wrap="square">
-            <a:spAutoFit/>
-          </a:bodyPr>
-          <a:lstStyle/>
-          <a:p>
-            <a:pPr algn="r"/>
-            <a:r>
-              <a:rPr sz="1200" b="0">
-                <a:solidFill>
-                  <a:srgbClr val="C8C0DE"/>
-                </a:solidFill>
-                <a:latin typeface="Helvetica"/>
-                <a:ea typeface="Helvetica"/>
-                <a:cs typeface="Helvetica"/>
-              </a:rPr>
-              <a:t>01</a:t>
-            </a:r>
-          </a:p>
-        </p:txBody>
-      </p:sp>
-      <p:sp>
-        <p:nvSpPr>
-          <p:cNvPr id="4" name="Rectangle 3"/>
+          <p:cNvPr id="2" name="Rectangle 1"/>
           <p:cNvSpPr/>
           <p:nvPr/>
         </p:nvSpPr>
         <p:spPr>
           <a:xfrm>
-            <a:off x="822960" y="658368"/>
-            <a:ext cx="10515600" cy="10972"/>
+            <a:off x="12136831" y="0"/>
+            <a:ext cx="54864" cy="6858000"/>
           </a:xfrm>
           <a:prstGeom prst="rect">
             <a:avLst/>
           </a:prstGeom>
           <a:solidFill>
-            <a:srgbClr val="E8E4F2"/>
+            <a:srgbClr val="5234B7"/>
           </a:solidFill>
           <a:ln>
             <a:noFill/>
@@ -4207,7 +4600,7 @@
       </p:sp>
       <p:pic>
         <p:nvPicPr>
-          <p:cNvPr id="5" name="Picture 4" descr="etra-logo.png"/>
+          <p:cNvPr id="3" name="Picture 2" descr="etra-wordmark.png"/>
           <p:cNvPicPr>
             <a:picLocks noChangeAspect="1"/>
           </p:cNvPicPr>
@@ -4221,14 +4614,95 @@
         </p:blipFill>
         <p:spPr>
           <a:xfrm>
-            <a:off x="10698480" y="320040"/>
-            <a:ext cx="546157" cy="502920"/>
+            <a:off x="10561320" y="411480"/>
+            <a:ext cx="1206201" cy="320040"/>
           </a:xfrm>
           <a:prstGeom prst="rect">
             <a:avLst/>
           </a:prstGeom>
         </p:spPr>
       </p:pic>
+      <p:sp>
+        <p:nvSpPr>
+          <p:cNvPr id="4" name="TextBox 3"/>
+          <p:cNvSpPr txBox="1"/>
+          <p:nvPr/>
+        </p:nvSpPr>
+        <p:spPr>
+          <a:xfrm>
+            <a:off x="548640" y="438912"/>
+            <a:ext cx="7772400" cy="274320"/>
+          </a:xfrm>
+          <a:prstGeom prst="rect">
+            <a:avLst/>
+          </a:prstGeom>
+          <a:noFill/>
+        </p:spPr>
+        <p:txBody>
+          <a:bodyPr wrap="square" anchor="t">
+            <a:spAutoFit/>
+          </a:bodyPr>
+          <a:lstStyle/>
+          <a:p>
+            <a:pPr algn="l"/>
+            <a:r>
+              <a:rPr sz="1200" b="0">
+                <a:solidFill>
+                  <a:srgbClr val="5A5470"/>
+                </a:solidFill>
+                <a:latin typeface="DIN Next LT W23"/>
+                <a:ea typeface="DIN Next LT W23"/>
+                <a:cs typeface="DIN Next LT W23"/>
+              </a:rPr>
+              <a:t>S01  ·  Section</a:t>
+            </a:r>
+          </a:p>
+        </p:txBody>
+      </p:sp>
+      <p:sp>
+        <p:nvSpPr>
+          <p:cNvPr id="5" name="Rectangle 4"/>
+          <p:cNvSpPr/>
+          <p:nvPr/>
+        </p:nvSpPr>
+        <p:spPr>
+          <a:xfrm>
+            <a:off x="548640" y="822960"/>
+            <a:ext cx="11064240" cy="10972"/>
+          </a:xfrm>
+          <a:prstGeom prst="rect">
+            <a:avLst/>
+          </a:prstGeom>
+          <a:solidFill>
+            <a:srgbClr val="E4DCF4"/>
+          </a:solidFill>
+          <a:ln>
+            <a:noFill/>
+          </a:ln>
+          <a:effectLst/>
+        </p:spPr>
+        <p:style>
+          <a:lnRef idx="1">
+            <a:schemeClr val="accent1"/>
+          </a:lnRef>
+          <a:fillRef idx="3">
+            <a:schemeClr val="accent1"/>
+          </a:fillRef>
+          <a:effectRef idx="2">
+            <a:schemeClr val="accent1"/>
+          </a:effectRef>
+          <a:fontRef idx="minor">
+            <a:schemeClr val="lt1"/>
+          </a:fontRef>
+        </p:style>
+        <p:txBody>
+          <a:bodyPr rtlCol="0" anchor="ctr"/>
+          <a:lstStyle/>
+          <a:p>
+            <a:pPr algn="ctr"/>
+          </a:p>
+        </p:txBody>
+      </p:sp>
       <p:sp>
         <p:nvSpPr>
           <p:cNvPr id="6" name="TextBox 5"/>
@@ -4237,8 +4711,8 @@
         </p:nvSpPr>
         <p:spPr>
           <a:xfrm>
-            <a:off x="822960" y="960120"/>
-            <a:ext cx="10058400" cy="548640"/>
+            <a:off x="548640" y="1051560"/>
+            <a:ext cx="10241280" cy="594360"/>
           </a:xfrm>
           <a:prstGeom prst="rect">
             <a:avLst/>
@@ -4246,36 +4720,82 @@
           <a:noFill/>
         </p:spPr>
         <p:txBody>
-          <a:bodyPr wrap="square">
+          <a:bodyPr wrap="square" anchor="t">
             <a:spAutoFit/>
           </a:bodyPr>
           <a:lstStyle/>
           <a:p>
             <a:pPr algn="l"/>
             <a:r>
-              <a:rPr sz="2800" b="1">
+              <a:rPr sz="3200" b="1">
                 <a:solidFill>
-                  <a:srgbClr val="221E36"/>
+                  <a:srgbClr val="5234B7"/>
                 </a:solidFill>
-                <a:latin typeface="Helvetica"/>
-                <a:ea typeface="Helvetica"/>
-                <a:cs typeface="Helvetica"/>
+                <a:latin typeface="DIN Next LT W23"/>
+                <a:ea typeface="DIN Next LT W23"/>
+                <a:cs typeface="DIN Next LT W23"/>
               </a:rPr>
-              <a:t>Slide title</a:t>
-            </a:r>
-          </a:p>
-        </p:txBody>
-      </p:sp>
-      <p:sp>
-        <p:nvSpPr>
-          <p:cNvPr id="7" name="TextBox 6"/>
+              <a:t>Title + cards</a:t>
+            </a:r>
+          </a:p>
+        </p:txBody>
+      </p:sp>
+      <p:sp>
+        <p:nvSpPr>
+          <p:cNvPr id="7" name="Rounded Rectangle 6"/>
+          <p:cNvSpPr/>
+          <p:nvPr/>
+        </p:nvSpPr>
+        <p:spPr>
+          <a:xfrm>
+            <a:off x="548640" y="2103120"/>
+            <a:ext cx="5212080" cy="1737360"/>
+          </a:xfrm>
+          <a:prstGeom prst="roundRect">
+            <a:avLst>
+              <a:gd name="adj" fmla="val 10000"/>
+            </a:avLst>
+          </a:prstGeom>
+          <a:solidFill>
+            <a:srgbClr val="EEE8FA"/>
+          </a:solidFill>
+          <a:ln>
+            <a:noFill/>
+          </a:ln>
+          <a:effectLst/>
+        </p:spPr>
+        <p:style>
+          <a:lnRef idx="1">
+            <a:schemeClr val="accent1"/>
+          </a:lnRef>
+          <a:fillRef idx="3">
+            <a:schemeClr val="accent1"/>
+          </a:fillRef>
+          <a:effectRef idx="2">
+            <a:schemeClr val="accent1"/>
+          </a:effectRef>
+          <a:fontRef idx="minor">
+            <a:schemeClr val="lt1"/>
+          </a:fontRef>
+        </p:style>
+        <p:txBody>
+          <a:bodyPr rtlCol="0" anchor="ctr"/>
+          <a:lstStyle/>
+          <a:p>
+            <a:pPr algn="ctr"/>
+          </a:p>
+        </p:txBody>
+      </p:sp>
+      <p:sp>
+        <p:nvSpPr>
+          <p:cNvPr id="8" name="TextBox 7"/>
           <p:cNvSpPr txBox="1"/>
           <p:nvPr/>
         </p:nvSpPr>
         <p:spPr>
           <a:xfrm>
-            <a:off x="822960" y="1463040"/>
-            <a:ext cx="10058400" cy="320040"/>
+            <a:off x="868680" y="2423160"/>
+            <a:ext cx="4572000" cy="320040"/>
           </a:xfrm>
           <a:prstGeom prst="rect">
             <a:avLst/>
@@ -4283,36 +4803,36 @@
           <a:noFill/>
         </p:spPr>
         <p:txBody>
-          <a:bodyPr wrap="square">
+          <a:bodyPr wrap="square" anchor="t">
             <a:spAutoFit/>
           </a:bodyPr>
           <a:lstStyle/>
           <a:p>
             <a:pPr algn="l"/>
             <a:r>
-              <a:rPr sz="1500" b="0">
+              <a:rPr sz="1500" b="1">
                 <a:solidFill>
-                  <a:srgbClr val="7A7496"/>
+                  <a:srgbClr val="5234B7"/>
                 </a:solidFill>
-                <a:latin typeface="Helvetica"/>
-                <a:ea typeface="Helvetica"/>
-                <a:cs typeface="Helvetica"/>
+                <a:latin typeface="DIN Next LT W23"/>
+                <a:ea typeface="DIN Next LT W23"/>
+                <a:cs typeface="DIN Next LT W23"/>
               </a:rPr>
-              <a:t>Optional subtitle</a:t>
-            </a:r>
-          </a:p>
-        </p:txBody>
-      </p:sp>
-      <p:sp>
-        <p:nvSpPr>
-          <p:cNvPr id="8" name="TextBox 7"/>
+              <a:t>Card 1</a:t>
+            </a:r>
+          </a:p>
+        </p:txBody>
+      </p:sp>
+      <p:sp>
+        <p:nvSpPr>
+          <p:cNvPr id="9" name="TextBox 8"/>
           <p:cNvSpPr txBox="1"/>
           <p:nvPr/>
         </p:nvSpPr>
         <p:spPr>
           <a:xfrm>
-            <a:off x="822960" y="2194560"/>
-            <a:ext cx="320040" cy="365760"/>
+            <a:off x="868680" y="2880360"/>
+            <a:ext cx="4572000" cy="548640"/>
           </a:xfrm>
           <a:prstGeom prst="rect">
             <a:avLst/>
@@ -4320,36 +4840,82 @@
           <a:noFill/>
         </p:spPr>
         <p:txBody>
-          <a:bodyPr wrap="square">
+          <a:bodyPr wrap="square" anchor="t">
             <a:spAutoFit/>
           </a:bodyPr>
           <a:lstStyle/>
           <a:p>
             <a:pPr algn="l"/>
             <a:r>
-              <a:rPr sz="1800" b="0">
+              <a:rPr sz="1300" b="0">
                 <a:solidFill>
-                  <a:srgbClr val="C8C0DE"/>
+                  <a:srgbClr val="5A5470"/>
                 </a:solidFill>
-                <a:latin typeface="Helvetica"/>
-                <a:ea typeface="Helvetica"/>
-                <a:cs typeface="Helvetica"/>
+                <a:latin typeface="DIN Next LT W23"/>
+                <a:ea typeface="DIN Next LT W23"/>
+                <a:cs typeface="DIN Next LT W23"/>
               </a:rPr>
-              <a:t>–</a:t>
-            </a:r>
-          </a:p>
-        </p:txBody>
-      </p:sp>
-      <p:sp>
-        <p:nvSpPr>
-          <p:cNvPr id="9" name="TextBox 8"/>
+              <a:t>Supporting copy</a:t>
+            </a:r>
+          </a:p>
+        </p:txBody>
+      </p:sp>
+      <p:sp>
+        <p:nvSpPr>
+          <p:cNvPr id="10" name="Rounded Rectangle 9"/>
+          <p:cNvSpPr/>
+          <p:nvPr/>
+        </p:nvSpPr>
+        <p:spPr>
+          <a:xfrm>
+            <a:off x="6400800" y="2103120"/>
+            <a:ext cx="5212080" cy="1737360"/>
+          </a:xfrm>
+          <a:prstGeom prst="roundRect">
+            <a:avLst>
+              <a:gd name="adj" fmla="val 10000"/>
+            </a:avLst>
+          </a:prstGeom>
+          <a:solidFill>
+            <a:srgbClr val="EEE8FA"/>
+          </a:solidFill>
+          <a:ln>
+            <a:noFill/>
+          </a:ln>
+          <a:effectLst/>
+        </p:spPr>
+        <p:style>
+          <a:lnRef idx="1">
+            <a:schemeClr val="accent1"/>
+          </a:lnRef>
+          <a:fillRef idx="3">
+            <a:schemeClr val="accent1"/>
+          </a:fillRef>
+          <a:effectRef idx="2">
+            <a:schemeClr val="accent1"/>
+          </a:effectRef>
+          <a:fontRef idx="minor">
+            <a:schemeClr val="lt1"/>
+          </a:fontRef>
+        </p:style>
+        <p:txBody>
+          <a:bodyPr rtlCol="0" anchor="ctr"/>
+          <a:lstStyle/>
+          <a:p>
+            <a:pPr algn="ctr"/>
+          </a:p>
+        </p:txBody>
+      </p:sp>
+      <p:sp>
+        <p:nvSpPr>
+          <p:cNvPr id="11" name="TextBox 10"/>
           <p:cNvSpPr txBox="1"/>
           <p:nvPr/>
         </p:nvSpPr>
         <p:spPr>
           <a:xfrm>
-            <a:off x="1188720" y="2194560"/>
-            <a:ext cx="10058400" cy="411480"/>
+            <a:off x="6720840" y="2423160"/>
+            <a:ext cx="4572000" cy="320040"/>
           </a:xfrm>
           <a:prstGeom prst="rect">
             <a:avLst/>
@@ -4357,36 +4923,36 @@
           <a:noFill/>
         </p:spPr>
         <p:txBody>
-          <a:bodyPr wrap="square">
+          <a:bodyPr wrap="square" anchor="t">
             <a:spAutoFit/>
           </a:bodyPr>
           <a:lstStyle/>
           <a:p>
             <a:pPr algn="l"/>
             <a:r>
-              <a:rPr sz="1800" b="0">
+              <a:rPr sz="1500" b="1">
                 <a:solidFill>
-                  <a:srgbClr val="221E36"/>
+                  <a:srgbClr val="5234B7"/>
                 </a:solidFill>
-                <a:latin typeface="Helvetica"/>
-                <a:ea typeface="Helvetica"/>
-                <a:cs typeface="Helvetica"/>
+                <a:latin typeface="DIN Next LT W23"/>
+                <a:ea typeface="DIN Next LT W23"/>
+                <a:cs typeface="DIN Next LT W23"/>
               </a:rPr>
-              <a:t>First point</a:t>
-            </a:r>
-          </a:p>
-        </p:txBody>
-      </p:sp>
-      <p:sp>
-        <p:nvSpPr>
-          <p:cNvPr id="10" name="TextBox 9"/>
+              <a:t>Card 2</a:t>
+            </a:r>
+          </a:p>
+        </p:txBody>
+      </p:sp>
+      <p:sp>
+        <p:nvSpPr>
+          <p:cNvPr id="12" name="TextBox 11"/>
           <p:cNvSpPr txBox="1"/>
           <p:nvPr/>
         </p:nvSpPr>
         <p:spPr>
           <a:xfrm>
-            <a:off x="822960" y="2834640"/>
-            <a:ext cx="320040" cy="365760"/>
+            <a:off x="6720840" y="2880360"/>
+            <a:ext cx="4572000" cy="548640"/>
           </a:xfrm>
           <a:prstGeom prst="rect">
             <a:avLst/>
@@ -4394,36 +4960,82 @@
           <a:noFill/>
         </p:spPr>
         <p:txBody>
-          <a:bodyPr wrap="square">
+          <a:bodyPr wrap="square" anchor="t">
             <a:spAutoFit/>
           </a:bodyPr>
           <a:lstStyle/>
           <a:p>
             <a:pPr algn="l"/>
             <a:r>
-              <a:rPr sz="1800" b="0">
+              <a:rPr sz="1300" b="0">
                 <a:solidFill>
-                  <a:srgbClr val="C8C0DE"/>
+                  <a:srgbClr val="5A5470"/>
                 </a:solidFill>
-                <a:latin typeface="Helvetica"/>
-                <a:ea typeface="Helvetica"/>
-                <a:cs typeface="Helvetica"/>
+                <a:latin typeface="DIN Next LT W23"/>
+                <a:ea typeface="DIN Next LT W23"/>
+                <a:cs typeface="DIN Next LT W23"/>
               </a:rPr>
-              <a:t>–</a:t>
-            </a:r>
-          </a:p>
-        </p:txBody>
-      </p:sp>
-      <p:sp>
-        <p:nvSpPr>
-          <p:cNvPr id="11" name="TextBox 10"/>
+              <a:t>Supporting copy</a:t>
+            </a:r>
+          </a:p>
+        </p:txBody>
+      </p:sp>
+      <p:sp>
+        <p:nvSpPr>
+          <p:cNvPr id="13" name="Rounded Rectangle 12"/>
+          <p:cNvSpPr/>
+          <p:nvPr/>
+        </p:nvSpPr>
+        <p:spPr>
+          <a:xfrm>
+            <a:off x="548640" y="4069080"/>
+            <a:ext cx="5212080" cy="1737360"/>
+          </a:xfrm>
+          <a:prstGeom prst="roundRect">
+            <a:avLst>
+              <a:gd name="adj" fmla="val 10000"/>
+            </a:avLst>
+          </a:prstGeom>
+          <a:solidFill>
+            <a:srgbClr val="EEE8FA"/>
+          </a:solidFill>
+          <a:ln>
+            <a:noFill/>
+          </a:ln>
+          <a:effectLst/>
+        </p:spPr>
+        <p:style>
+          <a:lnRef idx="1">
+            <a:schemeClr val="accent1"/>
+          </a:lnRef>
+          <a:fillRef idx="3">
+            <a:schemeClr val="accent1"/>
+          </a:fillRef>
+          <a:effectRef idx="2">
+            <a:schemeClr val="accent1"/>
+          </a:effectRef>
+          <a:fontRef idx="minor">
+            <a:schemeClr val="lt1"/>
+          </a:fontRef>
+        </p:style>
+        <p:txBody>
+          <a:bodyPr rtlCol="0" anchor="ctr"/>
+          <a:lstStyle/>
+          <a:p>
+            <a:pPr algn="ctr"/>
+          </a:p>
+        </p:txBody>
+      </p:sp>
+      <p:sp>
+        <p:nvSpPr>
+          <p:cNvPr id="14" name="TextBox 13"/>
           <p:cNvSpPr txBox="1"/>
           <p:nvPr/>
         </p:nvSpPr>
         <p:spPr>
           <a:xfrm>
-            <a:off x="1188720" y="2834640"/>
-            <a:ext cx="10058400" cy="411480"/>
+            <a:off x="868680" y="4389120"/>
+            <a:ext cx="4572000" cy="320040"/>
           </a:xfrm>
           <a:prstGeom prst="rect">
             <a:avLst/>
@@ -4431,36 +5043,36 @@
           <a:noFill/>
         </p:spPr>
         <p:txBody>
-          <a:bodyPr wrap="square">
+          <a:bodyPr wrap="square" anchor="t">
             <a:spAutoFit/>
           </a:bodyPr>
           <a:lstStyle/>
           <a:p>
             <a:pPr algn="l"/>
             <a:r>
-              <a:rPr sz="1800" b="0">
+              <a:rPr sz="1500" b="1">
                 <a:solidFill>
-                  <a:srgbClr val="221E36"/>
+                  <a:srgbClr val="5234B7"/>
                 </a:solidFill>
-                <a:latin typeface="Helvetica"/>
-                <a:ea typeface="Helvetica"/>
-                <a:cs typeface="Helvetica"/>
+                <a:latin typeface="DIN Next LT W23"/>
+                <a:ea typeface="DIN Next LT W23"/>
+                <a:cs typeface="DIN Next LT W23"/>
               </a:rPr>
-              <a:t>Second point</a:t>
-            </a:r>
-          </a:p>
-        </p:txBody>
-      </p:sp>
-      <p:sp>
-        <p:nvSpPr>
-          <p:cNvPr id="12" name="TextBox 11"/>
+              <a:t>Card 3</a:t>
+            </a:r>
+          </a:p>
+        </p:txBody>
+      </p:sp>
+      <p:sp>
+        <p:nvSpPr>
+          <p:cNvPr id="15" name="TextBox 14"/>
           <p:cNvSpPr txBox="1"/>
           <p:nvPr/>
         </p:nvSpPr>
         <p:spPr>
           <a:xfrm>
-            <a:off x="822960" y="3474720"/>
-            <a:ext cx="320040" cy="365760"/>
+            <a:off x="868680" y="4846320"/>
+            <a:ext cx="4572000" cy="548640"/>
           </a:xfrm>
           <a:prstGeom prst="rect">
             <a:avLst/>
@@ -4468,36 +5080,82 @@
           <a:noFill/>
         </p:spPr>
         <p:txBody>
-          <a:bodyPr wrap="square">
+          <a:bodyPr wrap="square" anchor="t">
             <a:spAutoFit/>
           </a:bodyPr>
           <a:lstStyle/>
           <a:p>
             <a:pPr algn="l"/>
             <a:r>
-              <a:rPr sz="1800" b="0">
+              <a:rPr sz="1300" b="0">
                 <a:solidFill>
-                  <a:srgbClr val="C8C0DE"/>
+                  <a:srgbClr val="5A5470"/>
                 </a:solidFill>
-                <a:latin typeface="Helvetica"/>
-                <a:ea typeface="Helvetica"/>
-                <a:cs typeface="Helvetica"/>
+                <a:latin typeface="DIN Next LT W23"/>
+                <a:ea typeface="DIN Next LT W23"/>
+                <a:cs typeface="DIN Next LT W23"/>
               </a:rPr>
-              <a:t>–</a:t>
-            </a:r>
-          </a:p>
-        </p:txBody>
-      </p:sp>
-      <p:sp>
-        <p:nvSpPr>
-          <p:cNvPr id="13" name="TextBox 12"/>
+              <a:t>Supporting copy</a:t>
+            </a:r>
+          </a:p>
+        </p:txBody>
+      </p:sp>
+      <p:sp>
+        <p:nvSpPr>
+          <p:cNvPr id="16" name="Rounded Rectangle 15"/>
+          <p:cNvSpPr/>
+          <p:nvPr/>
+        </p:nvSpPr>
+        <p:spPr>
+          <a:xfrm>
+            <a:off x="6400800" y="4069080"/>
+            <a:ext cx="5212080" cy="1737360"/>
+          </a:xfrm>
+          <a:prstGeom prst="roundRect">
+            <a:avLst>
+              <a:gd name="adj" fmla="val 10000"/>
+            </a:avLst>
+          </a:prstGeom>
+          <a:solidFill>
+            <a:srgbClr val="EEE8FA"/>
+          </a:solidFill>
+          <a:ln>
+            <a:noFill/>
+          </a:ln>
+          <a:effectLst/>
+        </p:spPr>
+        <p:style>
+          <a:lnRef idx="1">
+            <a:schemeClr val="accent1"/>
+          </a:lnRef>
+          <a:fillRef idx="3">
+            <a:schemeClr val="accent1"/>
+          </a:fillRef>
+          <a:effectRef idx="2">
+            <a:schemeClr val="accent1"/>
+          </a:effectRef>
+          <a:fontRef idx="minor">
+            <a:schemeClr val="lt1"/>
+          </a:fontRef>
+        </p:style>
+        <p:txBody>
+          <a:bodyPr rtlCol="0" anchor="ctr"/>
+          <a:lstStyle/>
+          <a:p>
+            <a:pPr algn="ctr"/>
+          </a:p>
+        </p:txBody>
+      </p:sp>
+      <p:sp>
+        <p:nvSpPr>
+          <p:cNvPr id="17" name="TextBox 16"/>
           <p:cNvSpPr txBox="1"/>
           <p:nvPr/>
         </p:nvSpPr>
         <p:spPr>
           <a:xfrm>
-            <a:off x="1188720" y="3474720"/>
-            <a:ext cx="10058400" cy="411480"/>
+            <a:off x="6720840" y="4389120"/>
+            <a:ext cx="4572000" cy="320040"/>
           </a:xfrm>
           <a:prstGeom prst="rect">
             <a:avLst/>
@@ -4505,36 +5163,36 @@
           <a:noFill/>
         </p:spPr>
         <p:txBody>
-          <a:bodyPr wrap="square">
+          <a:bodyPr wrap="square" anchor="t">
             <a:spAutoFit/>
           </a:bodyPr>
           <a:lstStyle/>
           <a:p>
             <a:pPr algn="l"/>
             <a:r>
-              <a:rPr sz="1800" b="0">
+              <a:rPr sz="1500" b="1">
                 <a:solidFill>
-                  <a:srgbClr val="221E36"/>
+                  <a:srgbClr val="5234B7"/>
                 </a:solidFill>
-                <a:latin typeface="Helvetica"/>
-                <a:ea typeface="Helvetica"/>
-                <a:cs typeface="Helvetica"/>
+                <a:latin typeface="DIN Next LT W23"/>
+                <a:ea typeface="DIN Next LT W23"/>
+                <a:cs typeface="DIN Next LT W23"/>
               </a:rPr>
-              <a:t>Third point</a:t>
-            </a:r>
-          </a:p>
-        </p:txBody>
-      </p:sp>
-      <p:sp>
-        <p:nvSpPr>
-          <p:cNvPr id="14" name="TextBox 13"/>
+              <a:t>Card 4</a:t>
+            </a:r>
+          </a:p>
+        </p:txBody>
+      </p:sp>
+      <p:sp>
+        <p:nvSpPr>
+          <p:cNvPr id="18" name="TextBox 17"/>
           <p:cNvSpPr txBox="1"/>
           <p:nvPr/>
         </p:nvSpPr>
         <p:spPr>
           <a:xfrm>
-            <a:off x="822960" y="4114799"/>
-            <a:ext cx="320040" cy="365760"/>
+            <a:off x="6720840" y="4846320"/>
+            <a:ext cx="4572000" cy="548640"/>
           </a:xfrm>
           <a:prstGeom prst="rect">
             <a:avLst/>
@@ -4542,36 +5200,80 @@
           <a:noFill/>
         </p:spPr>
         <p:txBody>
-          <a:bodyPr wrap="square">
+          <a:bodyPr wrap="square" anchor="t">
             <a:spAutoFit/>
           </a:bodyPr>
           <a:lstStyle/>
           <a:p>
             <a:pPr algn="l"/>
             <a:r>
-              <a:rPr sz="1800" b="0">
+              <a:rPr sz="1300" b="0">
                 <a:solidFill>
-                  <a:srgbClr val="C8C0DE"/>
+                  <a:srgbClr val="5A5470"/>
                 </a:solidFill>
-                <a:latin typeface="Helvetica"/>
-                <a:ea typeface="Helvetica"/>
-                <a:cs typeface="Helvetica"/>
+                <a:latin typeface="DIN Next LT W23"/>
+                <a:ea typeface="DIN Next LT W23"/>
+                <a:cs typeface="DIN Next LT W23"/>
               </a:rPr>
-              <a:t>–</a:t>
-            </a:r>
-          </a:p>
-        </p:txBody>
-      </p:sp>
-      <p:sp>
-        <p:nvSpPr>
-          <p:cNvPr id="15" name="TextBox 14"/>
+              <a:t>Supporting copy</a:t>
+            </a:r>
+          </a:p>
+        </p:txBody>
+      </p:sp>
+      <p:sp>
+        <p:nvSpPr>
+          <p:cNvPr id="19" name="Rectangle 18"/>
+          <p:cNvSpPr/>
+          <p:nvPr/>
+        </p:nvSpPr>
+        <p:spPr>
+          <a:xfrm>
+            <a:off x="548640" y="6446520"/>
+            <a:ext cx="11064240" cy="10972"/>
+          </a:xfrm>
+          <a:prstGeom prst="rect">
+            <a:avLst/>
+          </a:prstGeom>
+          <a:solidFill>
+            <a:srgbClr val="5234B7"/>
+          </a:solidFill>
+          <a:ln>
+            <a:noFill/>
+          </a:ln>
+          <a:effectLst/>
+        </p:spPr>
+        <p:style>
+          <a:lnRef idx="1">
+            <a:schemeClr val="accent1"/>
+          </a:lnRef>
+          <a:fillRef idx="3">
+            <a:schemeClr val="accent1"/>
+          </a:fillRef>
+          <a:effectRef idx="2">
+            <a:schemeClr val="accent1"/>
+          </a:effectRef>
+          <a:fontRef idx="minor">
+            <a:schemeClr val="lt1"/>
+          </a:fontRef>
+        </p:style>
+        <p:txBody>
+          <a:bodyPr rtlCol="0" anchor="ctr"/>
+          <a:lstStyle/>
+          <a:p>
+            <a:pPr algn="ctr"/>
+          </a:p>
+        </p:txBody>
+      </p:sp>
+      <p:sp>
+        <p:nvSpPr>
+          <p:cNvPr id="20" name="TextBox 19"/>
           <p:cNvSpPr txBox="1"/>
           <p:nvPr/>
         </p:nvSpPr>
         <p:spPr>
           <a:xfrm>
-            <a:off x="1188720" y="4114799"/>
-            <a:ext cx="10058400" cy="411480"/>
+            <a:off x="548640" y="6510528"/>
+            <a:ext cx="2743200" cy="256032"/>
           </a:xfrm>
           <a:prstGeom prst="rect">
             <a:avLst/>
@@ -4579,22 +5281,59 @@
           <a:noFill/>
         </p:spPr>
         <p:txBody>
-          <a:bodyPr wrap="square">
+          <a:bodyPr wrap="square" anchor="t">
             <a:spAutoFit/>
           </a:bodyPr>
           <a:lstStyle/>
           <a:p>
             <a:pPr algn="l"/>
             <a:r>
-              <a:rPr sz="1800" b="0">
+              <a:rPr sz="1100" b="1">
                 <a:solidFill>
-                  <a:srgbClr val="221E36"/>
+                  <a:srgbClr val="5234B7"/>
                 </a:solidFill>
-                <a:latin typeface="Helvetica"/>
-                <a:ea typeface="Helvetica"/>
-                <a:cs typeface="Helvetica"/>
+                <a:latin typeface="DIN Next LT W23"/>
+                <a:ea typeface="DIN Next LT W23"/>
+                <a:cs typeface="DIN Next LT W23"/>
               </a:rPr>
-              <a:t>Fourth point</a:t>
+              <a:t>ETRA</a:t>
+            </a:r>
+          </a:p>
+        </p:txBody>
+      </p:sp>
+      <p:sp>
+        <p:nvSpPr>
+          <p:cNvPr id="21" name="TextBox 20"/>
+          <p:cNvSpPr txBox="1"/>
+          <p:nvPr/>
+        </p:nvSpPr>
+        <p:spPr>
+          <a:xfrm>
+            <a:off x="9601200" y="6510528"/>
+            <a:ext cx="2011680" cy="256032"/>
+          </a:xfrm>
+          <a:prstGeom prst="rect">
+            <a:avLst/>
+          </a:prstGeom>
+          <a:noFill/>
+        </p:spPr>
+        <p:txBody>
+          <a:bodyPr wrap="square" anchor="t">
+            <a:spAutoFit/>
+          </a:bodyPr>
+          <a:lstStyle/>
+          <a:p>
+            <a:pPr algn="r"/>
+            <a:r>
+              <a:rPr sz="1100" b="0">
+                <a:solidFill>
+                  <a:srgbClr val="5A5470"/>
+                </a:solidFill>
+                <a:latin typeface="DIN Next LT W23"/>
+                <a:ea typeface="DIN Next LT W23"/>
+                <a:cs typeface="DIN Next LT W23"/>
+              </a:rPr>
+              <a:t>04  /  06</a:t>
             </a:r>
           </a:p>
         </p:txBody>
@@ -4613,7 +5352,7 @@
     <p:bg>
       <p:bgPr>
         <a:solidFill>
-          <a:srgbClr val="FCFBFE"/>
+          <a:srgbClr val="FAF8FF"/>
         </a:solidFill>
         <a:effectLst/>
       </p:bgPr>
@@ -4627,94 +5366,20 @@
       <p:grpSpPr/>
       <p:sp>
         <p:nvSpPr>
-          <p:cNvPr id="2" name="TextBox 1"/>
-          <p:cNvSpPr txBox="1"/>
-          <p:nvPr/>
-        </p:nvSpPr>
-        <p:spPr>
-          <a:xfrm>
-            <a:off x="822960" y="292608"/>
-            <a:ext cx="7315200" cy="274320"/>
-          </a:xfrm>
-          <a:prstGeom prst="rect">
-            <a:avLst/>
-          </a:prstGeom>
-          <a:noFill/>
-        </p:spPr>
-        <p:txBody>
-          <a:bodyPr wrap="square">
-            <a:spAutoFit/>
-          </a:bodyPr>
-          <a:lstStyle/>
-          <a:p>
-            <a:pPr algn="l"/>
-            <a:r>
-              <a:rPr sz="1200" b="0">
-                <a:solidFill>
-                  <a:srgbClr val="7A7496"/>
-                </a:solidFill>
-                <a:latin typeface="Helvetica"/>
-                <a:ea typeface="Helvetica"/>
-                <a:cs typeface="Helvetica"/>
-              </a:rPr>
-              <a:t>Section  ·  Topic</a:t>
-            </a:r>
-          </a:p>
-        </p:txBody>
-      </p:sp>
-      <p:sp>
-        <p:nvSpPr>
-          <p:cNvPr id="3" name="TextBox 2"/>
-          <p:cNvSpPr txBox="1"/>
-          <p:nvPr/>
-        </p:nvSpPr>
-        <p:spPr>
-          <a:xfrm>
-            <a:off x="9326880" y="292608"/>
-            <a:ext cx="1280160" cy="274320"/>
-          </a:xfrm>
-          <a:prstGeom prst="rect">
-            <a:avLst/>
-          </a:prstGeom>
-          <a:noFill/>
-        </p:spPr>
-        <p:txBody>
-          <a:bodyPr wrap="square">
-            <a:spAutoFit/>
-          </a:bodyPr>
-          <a:lstStyle/>
-          <a:p>
-            <a:pPr algn="r"/>
-            <a:r>
-              <a:rPr sz="1200" b="0">
-                <a:solidFill>
-                  <a:srgbClr val="C8C0DE"/>
-                </a:solidFill>
-                <a:latin typeface="Helvetica"/>
-                <a:ea typeface="Helvetica"/>
-                <a:cs typeface="Helvetica"/>
-              </a:rPr>
-              <a:t>01</a:t>
-            </a:r>
-          </a:p>
-        </p:txBody>
-      </p:sp>
-      <p:sp>
-        <p:nvSpPr>
-          <p:cNvPr id="4" name="Rectangle 3"/>
+          <p:cNvPr id="2" name="Rectangle 1"/>
           <p:cNvSpPr/>
           <p:nvPr/>
         </p:nvSpPr>
         <p:spPr>
           <a:xfrm>
-            <a:off x="822960" y="658368"/>
-            <a:ext cx="10515600" cy="10972"/>
+            <a:off x="12136831" y="0"/>
+            <a:ext cx="54864" cy="6858000"/>
           </a:xfrm>
           <a:prstGeom prst="rect">
             <a:avLst/>
           </a:prstGeom>
           <a:solidFill>
-            <a:srgbClr val="E8E4F2"/>
+            <a:srgbClr val="5234B7"/>
           </a:solidFill>
           <a:ln>
             <a:noFill/>
@@ -4745,7 +5410,7 @@
       </p:sp>
       <p:pic>
         <p:nvPicPr>
-          <p:cNvPr id="5" name="Picture 4" descr="etra-logo.png"/>
+          <p:cNvPr id="3" name="Picture 2" descr="etra-wordmark.png"/>
           <p:cNvPicPr>
             <a:picLocks noChangeAspect="1"/>
           </p:cNvPicPr>
@@ -4759,8 +5424,8 @@
         </p:blipFill>
         <p:spPr>
           <a:xfrm>
-            <a:off x="10698480" y="320040"/>
-            <a:ext cx="546157" cy="502920"/>
+            <a:off x="10561320" y="411480"/>
+            <a:ext cx="1206201" cy="320040"/>
           </a:xfrm>
           <a:prstGeom prst="rect">
             <a:avLst/>
@@ -4769,14 +5434,14 @@
       </p:pic>
       <p:sp>
         <p:nvSpPr>
-          <p:cNvPr id="6" name="TextBox 5"/>
+          <p:cNvPr id="4" name="TextBox 3"/>
           <p:cNvSpPr txBox="1"/>
           <p:nvPr/>
         </p:nvSpPr>
         <p:spPr>
           <a:xfrm>
-            <a:off x="822960" y="960120"/>
-            <a:ext cx="10058400" cy="548640"/>
+            <a:off x="548640" y="438912"/>
+            <a:ext cx="7772400" cy="274320"/>
           </a:xfrm>
           <a:prstGeom prst="rect">
             <a:avLst/>
@@ -4784,81 +5449,42 @@
           <a:noFill/>
         </p:spPr>
         <p:txBody>
-          <a:bodyPr wrap="square">
+          <a:bodyPr wrap="square" anchor="t">
             <a:spAutoFit/>
           </a:bodyPr>
           <a:lstStyle/>
           <a:p>
             <a:pPr algn="l"/>
             <a:r>
-              <a:rPr sz="2800" b="1">
+              <a:rPr sz="1200" b="0">
                 <a:solidFill>
-                  <a:srgbClr val="221E36"/>
+                  <a:srgbClr val="5A5470"/>
                 </a:solidFill>
-                <a:latin typeface="Helvetica"/>
-                <a:ea typeface="Helvetica"/>
-                <a:cs typeface="Helvetica"/>
+                <a:latin typeface="DIN Next LT W23"/>
+                <a:ea typeface="DIN Next LT W23"/>
+                <a:cs typeface="DIN Next LT W23"/>
               </a:rPr>
-              <a:t>Two ideas</a:t>
-            </a:r>
-          </a:p>
-        </p:txBody>
-      </p:sp>
-      <p:sp>
-        <p:nvSpPr>
-          <p:cNvPr id="7" name="TextBox 6"/>
-          <p:cNvSpPr txBox="1"/>
-          <p:nvPr/>
-        </p:nvSpPr>
-        <p:spPr>
-          <a:xfrm>
-            <a:off x="822960" y="1463040"/>
-            <a:ext cx="10058400" cy="320040"/>
-          </a:xfrm>
-          <a:prstGeom prst="rect">
-            <a:avLst/>
-          </a:prstGeom>
-          <a:noFill/>
-        </p:spPr>
-        <p:txBody>
-          <a:bodyPr wrap="square">
-            <a:spAutoFit/>
-          </a:bodyPr>
-          <a:lstStyle/>
-          <a:p>
-            <a:pPr algn="l"/>
-            <a:r>
-              <a:rPr sz="1500" b="0">
-                <a:solidFill>
-                  <a:srgbClr val="7A7496"/>
-                </a:solidFill>
-                <a:latin typeface="Helvetica"/>
-                <a:ea typeface="Helvetica"/>
-                <a:cs typeface="Helvetica"/>
-              </a:rPr>
-              <a:t>Side by side</a:t>
-            </a:r>
-          </a:p>
-        </p:txBody>
-      </p:sp>
-      <p:sp>
-        <p:nvSpPr>
-          <p:cNvPr id="8" name="Rounded Rectangle 7"/>
+              <a:t>S01  ·  Section</a:t>
+            </a:r>
+          </a:p>
+        </p:txBody>
+      </p:sp>
+      <p:sp>
+        <p:nvSpPr>
+          <p:cNvPr id="5" name="Rectangle 4"/>
           <p:cNvSpPr/>
           <p:nvPr/>
         </p:nvSpPr>
         <p:spPr>
           <a:xfrm>
-            <a:off x="822960" y="2148840"/>
-            <a:ext cx="5029200" cy="3657600"/>
-          </a:xfrm>
-          <a:prstGeom prst="roundRect">
-            <a:avLst>
-              <a:gd name="adj" fmla="val 12000"/>
-            </a:avLst>
+            <a:off x="548640" y="822960"/>
+            <a:ext cx="11064240" cy="10972"/>
+          </a:xfrm>
+          <a:prstGeom prst="rect">
+            <a:avLst/>
           </a:prstGeom>
           <a:solidFill>
-            <a:srgbClr val="F4F2F9"/>
+            <a:srgbClr val="E4DCF4"/>
           </a:solidFill>
           <a:ln>
             <a:noFill/>
@@ -4889,22 +5515,57 @@
       </p:sp>
       <p:sp>
         <p:nvSpPr>
-          <p:cNvPr id="9" name="Rounded Rectangle 8"/>
+          <p:cNvPr id="6" name="TextBox 5"/>
+          <p:cNvSpPr txBox="1"/>
+          <p:nvPr/>
+        </p:nvSpPr>
+        <p:spPr>
+          <a:xfrm>
+            <a:off x="548640" y="2926080"/>
+            <a:ext cx="10972800" cy="1097280"/>
+          </a:xfrm>
+          <a:prstGeom prst="rect">
+            <a:avLst/>
+          </a:prstGeom>
+          <a:noFill/>
+        </p:spPr>
+        <p:txBody>
+          <a:bodyPr wrap="square" anchor="t">
+            <a:spAutoFit/>
+          </a:bodyPr>
+          <a:lstStyle/>
+          <a:p>
+            <a:pPr algn="ctr"/>
+            <a:r>
+              <a:rPr sz="2800" b="1">
+                <a:solidFill>
+                  <a:srgbClr val="5234B7"/>
+                </a:solidFill>
+                <a:latin typeface="DIN Next LT W23"/>
+                <a:ea typeface="DIN Next LT W23"/>
+                <a:cs typeface="DIN Next LT W23"/>
+              </a:rPr>
+              <a:t>“A short centered message or quote.”</a:t>
+            </a:r>
+          </a:p>
+        </p:txBody>
+      </p:sp>
+      <p:sp>
+        <p:nvSpPr>
+          <p:cNvPr id="7" name="Rectangle 6"/>
           <p:cNvSpPr/>
           <p:nvPr/>
         </p:nvSpPr>
         <p:spPr>
           <a:xfrm>
-            <a:off x="6400800" y="2148840"/>
-            <a:ext cx="5029200" cy="3657600"/>
-          </a:xfrm>
-          <a:prstGeom prst="roundRect">
-            <a:avLst>
-              <a:gd name="adj" fmla="val 12000"/>
-            </a:avLst>
+            <a:off x="548640" y="6446520"/>
+            <a:ext cx="11064240" cy="10972"/>
+          </a:xfrm>
+          <a:prstGeom prst="rect">
+            <a:avLst/>
           </a:prstGeom>
           <a:solidFill>
-            <a:srgbClr val="F4F2F9"/>
+            <a:srgbClr val="5234B7"/>
           </a:solidFill>
           <a:ln>
             <a:noFill/>
@@ -4935,14 +5596,14 @@
       </p:sp>
       <p:sp>
         <p:nvSpPr>
-          <p:cNvPr id="10" name="TextBox 9"/>
+          <p:cNvPr id="8" name="TextBox 7"/>
           <p:cNvSpPr txBox="1"/>
           <p:nvPr/>
         </p:nvSpPr>
         <p:spPr>
           <a:xfrm>
-            <a:off x="1188720" y="2468880"/>
-            <a:ext cx="4297680" cy="365760"/>
+            <a:off x="548640" y="6510528"/>
+            <a:ext cx="2743200" cy="256032"/>
           </a:xfrm>
           <a:prstGeom prst="rect">
             <a:avLst/>
@@ -4950,36 +5611,36 @@
           <a:noFill/>
         </p:spPr>
         <p:txBody>
-          <a:bodyPr wrap="square">
+          <a:bodyPr wrap="square" anchor="t">
             <a:spAutoFit/>
           </a:bodyPr>
           <a:lstStyle/>
           <a:p>
             <a:pPr algn="l"/>
             <a:r>
-              <a:rPr sz="1600" b="1">
+              <a:rPr sz="1100" b="1">
                 <a:solidFill>
-                  <a:srgbClr val="221E36"/>
+                  <a:srgbClr val="5234B7"/>
                 </a:solidFill>
-                <a:latin typeface="Helvetica"/>
-                <a:ea typeface="Helvetica"/>
-                <a:cs typeface="Helvetica"/>
+                <a:latin typeface="DIN Next LT W23"/>
+                <a:ea typeface="DIN Next LT W23"/>
+                <a:cs typeface="DIN Next LT W23"/>
               </a:rPr>
-              <a:t>Left</a:t>
-            </a:r>
-          </a:p>
-        </p:txBody>
-      </p:sp>
-      <p:sp>
-        <p:nvSpPr>
-          <p:cNvPr id="11" name="TextBox 10"/>
+              <a:t>ETRA</a:t>
+            </a:r>
+          </a:p>
+        </p:txBody>
+      </p:sp>
+      <p:sp>
+        <p:nvSpPr>
+          <p:cNvPr id="9" name="TextBox 8"/>
           <p:cNvSpPr txBox="1"/>
           <p:nvPr/>
         </p:nvSpPr>
         <p:spPr>
           <a:xfrm>
-            <a:off x="6766560" y="2468880"/>
-            <a:ext cx="4297680" cy="365760"/>
+            <a:off x="9601200" y="6510528"/>
+            <a:ext cx="2011680" cy="256032"/>
           </a:xfrm>
           <a:prstGeom prst="rect">
             <a:avLst/>
@@ -4987,96 +5648,22 @@
           <a:noFill/>
         </p:spPr>
         <p:txBody>
-          <a:bodyPr wrap="square">
+          <a:bodyPr wrap="square" anchor="t">
             <a:spAutoFit/>
           </a:bodyPr>
           <a:lstStyle/>
           <a:p>
-            <a:pPr algn="l"/>
-            <a:r>
-              <a:rPr sz="1600" b="1">
+            <a:pPr algn="r"/>
+            <a:r>
+              <a:rPr sz="1100" b="0">
                 <a:solidFill>
-                  <a:srgbClr val="221E36"/>
+                  <a:srgbClr val="5A5470"/>
                 </a:solidFill>
-                <a:latin typeface="Helvetica"/>
-                <a:ea typeface="Helvetica"/>
-                <a:cs typeface="Helvetica"/>
+                <a:latin typeface="DIN Next LT W23"/>
+                <a:ea typeface="DIN Next LT W23"/>
+                <a:cs typeface="DIN Next LT W23"/>
               </a:rPr>
-              <a:t>Right</a:t>
-            </a:r>
-          </a:p>
-        </p:txBody>
-      </p:sp>
-      <p:sp>
-        <p:nvSpPr>
-          <p:cNvPr id="12" name="TextBox 11"/>
-          <p:cNvSpPr txBox="1"/>
-          <p:nvPr/>
-        </p:nvSpPr>
-        <p:spPr>
-          <a:xfrm>
-            <a:off x="1188720" y="3017520"/>
-            <a:ext cx="4297680" cy="1828800"/>
-          </a:xfrm>
-          <a:prstGeom prst="rect">
-            <a:avLst/>
-          </a:prstGeom>
-          <a:noFill/>
-        </p:spPr>
-        <p:txBody>
-          <a:bodyPr wrap="square">
-            <a:spAutoFit/>
-          </a:bodyPr>
-          <a:lstStyle/>
-          <a:p>
-            <a:pPr algn="l"/>
-            <a:r>
-              <a:rPr sz="1400" b="0">
-                <a:solidFill>
-                  <a:srgbClr val="7A7496"/>
-                </a:solidFill>
-                <a:latin typeface="Helvetica"/>
-                <a:ea typeface="Helvetica"/>
-                <a:cs typeface="Helvetica"/>
-              </a:rPr>
-              <a:t>Supporting copy</a:t>
-            </a:r>
-          </a:p>
-        </p:txBody>
-      </p:sp>
-      <p:sp>
-        <p:nvSpPr>
-          <p:cNvPr id="13" name="TextBox 12"/>
-          <p:cNvSpPr txBox="1"/>
-          <p:nvPr/>
-        </p:nvSpPr>
-        <p:spPr>
-          <a:xfrm>
-            <a:off x="6766560" y="3017520"/>
-            <a:ext cx="4297680" cy="1828800"/>
-          </a:xfrm>
-          <a:prstGeom prst="rect">
-            <a:avLst/>
-          </a:prstGeom>
-          <a:noFill/>
-        </p:spPr>
-        <p:txBody>
-          <a:bodyPr wrap="square">
-            <a:spAutoFit/>
-          </a:bodyPr>
-          <a:lstStyle/>
-          <a:p>
-            <a:pPr algn="l"/>
-            <a:r>
-              <a:rPr sz="1400" b="0">
-                <a:solidFill>
-                  <a:srgbClr val="7A7496"/>
-                </a:solidFill>
-                <a:latin typeface="Helvetica"/>
-                <a:ea typeface="Helvetica"/>
-                <a:cs typeface="Helvetica"/>
-              </a:rPr>
-              <a:t>Supporting copy</a:t>
+              <a:t>05  /  06</a:t>
             </a:r>
           </a:p>
         </p:txBody>
@@ -5095,7 +5682,7 @@
     <p:bg>
       <p:bgPr>
         <a:solidFill>
-          <a:srgbClr val="FCFBFE"/>
+          <a:srgbClr val="0A0614"/>
         </a:solidFill>
         <a:effectLst/>
       </p:bgPr>
@@ -5109,94 +5696,20 @@
       <p:grpSpPr/>
       <p:sp>
         <p:nvSpPr>
-          <p:cNvPr id="2" name="TextBox 1"/>
-          <p:cNvSpPr txBox="1"/>
-          <p:nvPr/>
-        </p:nvSpPr>
-        <p:spPr>
-          <a:xfrm>
-            <a:off x="822960" y="292608"/>
-            <a:ext cx="7315200" cy="274320"/>
-          </a:xfrm>
-          <a:prstGeom prst="rect">
-            <a:avLst/>
-          </a:prstGeom>
-          <a:noFill/>
-        </p:spPr>
-        <p:txBody>
-          <a:bodyPr wrap="square">
-            <a:spAutoFit/>
-          </a:bodyPr>
-          <a:lstStyle/>
-          <a:p>
-            <a:pPr algn="l"/>
-            <a:r>
-              <a:rPr sz="1200" b="0">
-                <a:solidFill>
-                  <a:srgbClr val="7A7496"/>
-                </a:solidFill>
-                <a:latin typeface="Helvetica"/>
-                <a:ea typeface="Helvetica"/>
-                <a:cs typeface="Helvetica"/>
-              </a:rPr>
-              <a:t>Section  ·  Topic</a:t>
-            </a:r>
-          </a:p>
-        </p:txBody>
-      </p:sp>
-      <p:sp>
-        <p:nvSpPr>
-          <p:cNvPr id="3" name="TextBox 2"/>
-          <p:cNvSpPr txBox="1"/>
-          <p:nvPr/>
-        </p:nvSpPr>
-        <p:spPr>
-          <a:xfrm>
-            <a:off x="9326880" y="292608"/>
-            <a:ext cx="1280160" cy="274320"/>
-          </a:xfrm>
-          <a:prstGeom prst="rect">
-            <a:avLst/>
-          </a:prstGeom>
-          <a:noFill/>
-        </p:spPr>
-        <p:txBody>
-          <a:bodyPr wrap="square">
-            <a:spAutoFit/>
-          </a:bodyPr>
-          <a:lstStyle/>
-          <a:p>
-            <a:pPr algn="r"/>
-            <a:r>
-              <a:rPr sz="1200" b="0">
-                <a:solidFill>
-                  <a:srgbClr val="C8C0DE"/>
-                </a:solidFill>
-                <a:latin typeface="Helvetica"/>
-                <a:ea typeface="Helvetica"/>
-                <a:cs typeface="Helvetica"/>
-              </a:rPr>
-              <a:t>01</a:t>
-            </a:r>
-          </a:p>
-        </p:txBody>
-      </p:sp>
-      <p:sp>
-        <p:nvSpPr>
-          <p:cNvPr id="4" name="Rectangle 3"/>
+          <p:cNvPr id="2" name="Oval 1"/>
           <p:cNvSpPr/>
           <p:nvPr/>
         </p:nvSpPr>
         <p:spPr>
           <a:xfrm>
-            <a:off x="822960" y="658368"/>
-            <a:ext cx="10515600" cy="10972"/>
-          </a:xfrm>
-          <a:prstGeom prst="rect">
+            <a:off x="3200400" y="731520"/>
+            <a:ext cx="5943600" cy="5029200"/>
+          </a:xfrm>
+          <a:prstGeom prst="ellipse">
             <a:avLst/>
           </a:prstGeom>
           <a:solidFill>
-            <a:srgbClr val="E8E4F2"/>
+            <a:srgbClr val="2A1860"/>
           </a:solidFill>
           <a:ln>
             <a:noFill/>
@@ -5227,7 +5740,7 @@
       </p:sp>
       <p:pic>
         <p:nvPicPr>
-          <p:cNvPr id="5" name="Picture 4" descr="etra-logo.png"/>
+          <p:cNvPr id="3" name="Picture 2" descr="etra-wordmark.png"/>
           <p:cNvPicPr>
             <a:picLocks noChangeAspect="1"/>
           </p:cNvPicPr>
@@ -5241,14 +5754,88 @@
         </p:blipFill>
         <p:spPr>
           <a:xfrm>
-            <a:off x="10698480" y="320040"/>
-            <a:ext cx="546157" cy="502920"/>
+            <a:off x="10561320" y="411480"/>
+            <a:ext cx="1378516" cy="365760"/>
           </a:xfrm>
           <a:prstGeom prst="rect">
             <a:avLst/>
           </a:prstGeom>
         </p:spPr>
       </p:pic>
+      <p:sp>
+        <p:nvSpPr>
+          <p:cNvPr id="4" name="TextBox 3"/>
+          <p:cNvSpPr txBox="1"/>
+          <p:nvPr/>
+        </p:nvSpPr>
+        <p:spPr>
+          <a:xfrm>
+            <a:off x="548640" y="2743200"/>
+            <a:ext cx="10972800" cy="731520"/>
+          </a:xfrm>
+          <a:prstGeom prst="rect">
+            <a:avLst/>
+          </a:prstGeom>
+          <a:noFill/>
+        </p:spPr>
+        <p:txBody>
+          <a:bodyPr wrap="square" anchor="t">
+            <a:spAutoFit/>
+          </a:bodyPr>
+          <a:lstStyle/>
+          <a:p>
+            <a:pPr algn="ctr"/>
+            <a:r>
+              <a:rPr sz="4000" b="1">
+                <a:solidFill>
+                  <a:srgbClr val="FFFFFF"/>
+                </a:solidFill>
+                <a:latin typeface="DIN Next LT W23"/>
+                <a:ea typeface="DIN Next LT W23"/>
+                <a:cs typeface="DIN Next LT W23"/>
+              </a:rPr>
+              <a:t>Thank you</a:t>
+            </a:r>
+          </a:p>
+        </p:txBody>
+      </p:sp>
+      <p:sp>
+        <p:nvSpPr>
+          <p:cNvPr id="5" name="TextBox 4"/>
+          <p:cNvSpPr txBox="1"/>
+          <p:nvPr/>
+        </p:nvSpPr>
+        <p:spPr>
+          <a:xfrm>
+            <a:off x="548640" y="3566160"/>
+            <a:ext cx="10972800" cy="365760"/>
+          </a:xfrm>
+          <a:prstGeom prst="rect">
+            <a:avLst/>
+          </a:prstGeom>
+          <a:noFill/>
+        </p:spPr>
+        <p:txBody>
+          <a:bodyPr wrap="square" anchor="t">
+            <a:spAutoFit/>
+          </a:bodyPr>
+          <a:lstStyle/>
+          <a:p>
+            <a:pPr algn="ctr"/>
+            <a:r>
+              <a:rPr sz="1600" b="0">
+                <a:solidFill>
+                  <a:srgbClr val="9E59CD"/>
+                </a:solidFill>
+                <a:latin typeface="DIN Next LT W23"/>
+                <a:ea typeface="DIN Next LT W23"/>
+                <a:cs typeface="DIN Next LT W23"/>
+              </a:rPr>
+              <a:t>@etrahub</a:t>
+            </a:r>
+          </a:p>
+        </p:txBody>
+      </p:sp>
       <p:sp>
         <p:nvSpPr>
           <p:cNvPr id="6" name="TextBox 5"/>
@@ -5257,8 +5844,8 @@
         </p:nvSpPr>
         <p:spPr>
           <a:xfrm>
-            <a:off x="822960" y="960120"/>
-            <a:ext cx="10058400" cy="548640"/>
+            <a:off x="548640" y="6126480"/>
+            <a:ext cx="3657600" cy="274320"/>
           </a:xfrm>
           <a:prstGeom prst="rect">
             <a:avLst/>
@@ -5266,393 +5853,22 @@
           <a:noFill/>
         </p:spPr>
         <p:txBody>
-          <a:bodyPr wrap="square">
+          <a:bodyPr wrap="square" anchor="t">
             <a:spAutoFit/>
           </a:bodyPr>
           <a:lstStyle/>
           <a:p>
             <a:pPr algn="l"/>
             <a:r>
-              <a:rPr sz="2800" b="1">
+              <a:rPr sz="1200" b="1">
                 <a:solidFill>
-                  <a:srgbClr val="221E36"/>
+                  <a:srgbClr val="9E59CD"/>
                 </a:solidFill>
-                <a:latin typeface="Helvetica"/>
-                <a:ea typeface="Helvetica"/>
-                <a:cs typeface="Helvetica"/>
+                <a:latin typeface="DIN Next LT W23"/>
+                <a:ea typeface="DIN Next LT W23"/>
+                <a:cs typeface="DIN Next LT W23"/>
               </a:rPr>
-              <a:t>Concept title</a:t>
-            </a:r>
-          </a:p>
-        </p:txBody>
-      </p:sp>
-      <p:sp>
-        <p:nvSpPr>
-          <p:cNvPr id="7" name="TextBox 6"/>
-          <p:cNvSpPr txBox="1"/>
-          <p:nvPr/>
-        </p:nvSpPr>
-        <p:spPr>
-          <a:xfrm>
-            <a:off x="822960" y="1463040"/>
-            <a:ext cx="10058400" cy="320040"/>
-          </a:xfrm>
-          <a:prstGeom prst="rect">
-            <a:avLst/>
-          </a:prstGeom>
-          <a:noFill/>
-        </p:spPr>
-        <p:txBody>
-          <a:bodyPr wrap="square">
-            <a:spAutoFit/>
-          </a:bodyPr>
-          <a:lstStyle/>
-          <a:p>
-            <a:pPr algn="l"/>
-            <a:r>
-              <a:rPr sz="1500" b="0">
-                <a:solidFill>
-                  <a:srgbClr val="7A7496"/>
-                </a:solidFill>
-                <a:latin typeface="Helvetica"/>
-                <a:ea typeface="Helvetica"/>
-                <a:cs typeface="Helvetica"/>
-              </a:rPr>
-              <a:t>Definition or explanation</a:t>
-            </a:r>
-          </a:p>
-        </p:txBody>
-      </p:sp>
-      <p:sp>
-        <p:nvSpPr>
-          <p:cNvPr id="8" name="Rounded Rectangle 7"/>
-          <p:cNvSpPr/>
-          <p:nvPr/>
-        </p:nvSpPr>
-        <p:spPr>
-          <a:xfrm>
-            <a:off x="822960" y="2148840"/>
-            <a:ext cx="10515600" cy="3657600"/>
-          </a:xfrm>
-          <a:prstGeom prst="roundRect">
-            <a:avLst>
-              <a:gd name="adj" fmla="val 12000"/>
-            </a:avLst>
-          </a:prstGeom>
-          <a:solidFill>
-            <a:srgbClr val="F4F2F9"/>
-          </a:solidFill>
-          <a:ln>
-            <a:noFill/>
-          </a:ln>
-          <a:effectLst/>
-        </p:spPr>
-        <p:style>
-          <a:lnRef idx="1">
-            <a:schemeClr val="accent1"/>
-          </a:lnRef>
-          <a:fillRef idx="3">
-            <a:schemeClr val="accent1"/>
-          </a:fillRef>
-          <a:effectRef idx="2">
-            <a:schemeClr val="accent1"/>
-          </a:effectRef>
-          <a:fontRef idx="minor">
-            <a:schemeClr val="lt1"/>
-          </a:fontRef>
-        </p:style>
-        <p:txBody>
-          <a:bodyPr rtlCol="0" anchor="ctr"/>
-          <a:lstStyle/>
-          <a:p>
-            <a:pPr algn="ctr"/>
-          </a:p>
-        </p:txBody>
-      </p:sp>
-      <p:sp>
-        <p:nvSpPr>
-          <p:cNvPr id="9" name="TextBox 8"/>
-          <p:cNvSpPr txBox="1"/>
-          <p:nvPr/>
-        </p:nvSpPr>
-        <p:spPr>
-          <a:xfrm>
-            <a:off x="1280160" y="3383280"/>
-            <a:ext cx="9601200" cy="914400"/>
-          </a:xfrm>
-          <a:prstGeom prst="rect">
-            <a:avLst/>
-          </a:prstGeom>
-          <a:noFill/>
-        </p:spPr>
-        <p:txBody>
-          <a:bodyPr wrap="square">
-            <a:spAutoFit/>
-          </a:bodyPr>
-          <a:lstStyle/>
-          <a:p>
-            <a:pPr algn="ctr"/>
-            <a:r>
-              <a:rPr sz="1800" b="0">
-                <a:solidFill>
-                  <a:srgbClr val="7A7496"/>
-                </a:solidFill>
-                <a:latin typeface="Helvetica"/>
-                <a:ea typeface="Helvetica"/>
-                <a:cs typeface="Helvetica"/>
-              </a:rPr>
-              <a:t>Body paragraph goes here.</a:t>
-            </a:r>
-          </a:p>
-        </p:txBody>
-      </p:sp>
-    </p:spTree>
-  </p:cSld>
-  <p:clrMapOvr>
-    <a:masterClrMapping/>
-  </p:clrMapOvr>
-</p:sld>
-</file>
-
-<file path=ppt/slides/slide7.xml><?xml version="1.0" encoding="utf-8"?>
-<p:sld xmlns:a="http://schemas.openxmlformats.org/drawingml/2006/main" xmlns:p="http://schemas.openxmlformats.org/presentationml/2006/main" xmlns:r="http://schemas.openxmlformats.org/officeDocument/2006/relationships">
-  <p:cSld>
-    <p:bg>
-      <p:bgPr>
-        <a:solidFill>
-          <a:srgbClr val="FCFBFE"/>
-        </a:solidFill>
-        <a:effectLst/>
-      </p:bgPr>
-    </p:bg>
-    <p:spTree>
-      <p:nvGrpSpPr>
-        <p:cNvPr id="1" name=""/>
-        <p:cNvGrpSpPr/>
-        <p:nvPr/>
-      </p:nvGrpSpPr>
-      <p:grpSpPr/>
-      <p:sp>
-        <p:nvSpPr>
-          <p:cNvPr id="2" name="TextBox 1"/>
-          <p:cNvSpPr txBox="1"/>
-          <p:nvPr/>
-        </p:nvSpPr>
-        <p:spPr>
-          <a:xfrm>
-            <a:off x="822960" y="292608"/>
-            <a:ext cx="7315200" cy="274320"/>
-          </a:xfrm>
-          <a:prstGeom prst="rect">
-            <a:avLst/>
-          </a:prstGeom>
-          <a:noFill/>
-        </p:spPr>
-        <p:txBody>
-          <a:bodyPr wrap="square">
-            <a:spAutoFit/>
-          </a:bodyPr>
-          <a:lstStyle/>
-          <a:p>
-            <a:pPr algn="l"/>
-            <a:r>
-              <a:rPr sz="1200" b="0">
-                <a:solidFill>
-                  <a:srgbClr val="7A7496"/>
-                </a:solidFill>
-                <a:latin typeface="Helvetica"/>
-                <a:ea typeface="Helvetica"/>
-                <a:cs typeface="Helvetica"/>
-              </a:rPr>
-              <a:t>Section  ·  Topic</a:t>
-            </a:r>
-          </a:p>
-        </p:txBody>
-      </p:sp>
-      <p:sp>
-        <p:nvSpPr>
-          <p:cNvPr id="3" name="TextBox 2"/>
-          <p:cNvSpPr txBox="1"/>
-          <p:nvPr/>
-        </p:nvSpPr>
-        <p:spPr>
-          <a:xfrm>
-            <a:off x="9326880" y="292608"/>
-            <a:ext cx="1280160" cy="274320"/>
-          </a:xfrm>
-          <a:prstGeom prst="rect">
-            <a:avLst/>
-          </a:prstGeom>
-          <a:noFill/>
-        </p:spPr>
-        <p:txBody>
-          <a:bodyPr wrap="square">
-            <a:spAutoFit/>
-          </a:bodyPr>
-          <a:lstStyle/>
-          <a:p>
-            <a:pPr algn="r"/>
-            <a:r>
-              <a:rPr sz="1200" b="0">
-                <a:solidFill>
-                  <a:srgbClr val="C8C0DE"/>
-                </a:solidFill>
-                <a:latin typeface="Helvetica"/>
-                <a:ea typeface="Helvetica"/>
-                <a:cs typeface="Helvetica"/>
-              </a:rPr>
-              <a:t>01</a:t>
-            </a:r>
-          </a:p>
-        </p:txBody>
-      </p:sp>
-      <p:sp>
-        <p:nvSpPr>
-          <p:cNvPr id="4" name="Rectangle 3"/>
-          <p:cNvSpPr/>
-          <p:nvPr/>
-        </p:nvSpPr>
-        <p:spPr>
-          <a:xfrm>
-            <a:off x="822960" y="658368"/>
-            <a:ext cx="10515600" cy="10972"/>
-          </a:xfrm>
-          <a:prstGeom prst="rect">
-            <a:avLst/>
-          </a:prstGeom>
-          <a:solidFill>
-            <a:srgbClr val="E8E4F2"/>
-          </a:solidFill>
-          <a:ln>
-            <a:noFill/>
-          </a:ln>
-          <a:effectLst/>
-        </p:spPr>
-        <p:style>
-          <a:lnRef idx="1">
-            <a:schemeClr val="accent1"/>
-          </a:lnRef>
-          <a:fillRef idx="3">
-            <a:schemeClr val="accent1"/>
-          </a:fillRef>
-          <a:effectRef idx="2">
-            <a:schemeClr val="accent1"/>
-          </a:effectRef>
-          <a:fontRef idx="minor">
-            <a:schemeClr val="lt1"/>
-          </a:fontRef>
-        </p:style>
-        <p:txBody>
-          <a:bodyPr rtlCol="0" anchor="ctr"/>
-          <a:lstStyle/>
-          <a:p>
-            <a:pPr algn="ctr"/>
-          </a:p>
-        </p:txBody>
-      </p:sp>
-      <p:pic>
-        <p:nvPicPr>
-          <p:cNvPr id="5" name="Picture 4" descr="etra-logo.png"/>
-          <p:cNvPicPr>
-            <a:picLocks noChangeAspect="1"/>
-          </p:cNvPicPr>
-          <p:nvPr/>
-        </p:nvPicPr>
-        <p:blipFill>
-          <a:blip r:embed="rId2"/>
-          <a:stretch>
-            <a:fillRect/>
-          </a:stretch>
-        </p:blipFill>
-        <p:spPr>
-          <a:xfrm>
-            <a:off x="10698480" y="320040"/>
-            <a:ext cx="546157" cy="502920"/>
-          </a:xfrm>
-          <a:prstGeom prst="rect">
-            <a:avLst/>
-          </a:prstGeom>
-        </p:spPr>
-      </p:pic>
-      <p:sp>
-        <p:nvSpPr>
-          <p:cNvPr id="6" name="Rounded Rectangle 5"/>
-          <p:cNvSpPr/>
-          <p:nvPr/>
-        </p:nvSpPr>
-        <p:spPr>
-          <a:xfrm>
-            <a:off x="822960" y="1097280"/>
-            <a:ext cx="10515600" cy="4937760"/>
-          </a:xfrm>
-          <a:prstGeom prst="roundRect">
-            <a:avLst>
-              <a:gd name="adj" fmla="val 12000"/>
-            </a:avLst>
-          </a:prstGeom>
-          <a:solidFill>
-            <a:srgbClr val="F4F2F9"/>
-          </a:solidFill>
-          <a:ln>
-            <a:noFill/>
-          </a:ln>
-          <a:effectLst/>
-        </p:spPr>
-        <p:style>
-          <a:lnRef idx="1">
-            <a:schemeClr val="accent1"/>
-          </a:lnRef>
-          <a:fillRef idx="3">
-            <a:schemeClr val="accent1"/>
-          </a:fillRef>
-          <a:effectRef idx="2">
-            <a:schemeClr val="accent1"/>
-          </a:effectRef>
-          <a:fontRef idx="minor">
-            <a:schemeClr val="lt1"/>
-          </a:fontRef>
-        </p:style>
-        <p:txBody>
-          <a:bodyPr rtlCol="0" anchor="ctr"/>
-          <a:lstStyle/>
-          <a:p>
-            <a:pPr algn="ctr"/>
-          </a:p>
-        </p:txBody>
-      </p:sp>
-      <p:sp>
-        <p:nvSpPr>
-          <p:cNvPr id="7" name="TextBox 6"/>
-          <p:cNvSpPr txBox="1"/>
-          <p:nvPr/>
-        </p:nvSpPr>
-        <p:spPr>
-          <a:xfrm>
-            <a:off x="822960" y="3200400"/>
-            <a:ext cx="10515600" cy="457200"/>
-          </a:xfrm>
-          <a:prstGeom prst="rect">
-            <a:avLst/>
-          </a:prstGeom>
-          <a:noFill/>
-        </p:spPr>
-        <p:txBody>
-          <a:bodyPr wrap="square">
-            <a:spAutoFit/>
-          </a:bodyPr>
-          <a:lstStyle/>
-          <a:p>
-            <a:pPr algn="ctr"/>
-            <a:r>
-              <a:rPr sz="1600" b="0">
-                <a:solidFill>
-                  <a:srgbClr val="C8C0DE"/>
-                </a:solidFill>
-                <a:latin typeface="Helvetica"/>
-                <a:ea typeface="Helvetica"/>
-                <a:cs typeface="Helvetica"/>
-              </a:rPr>
-              <a:t>Visual / diagram area</a:t>
+              <a:t>ETRA</a:t>
             </a:r>
           </a:p>
         </p:txBody>

</xml_diff>

<commit_message>
feat: update PowerPoint templates and scripts to implement light theme design, enhancing visual consistency and branding
</commit_message>
<xml_diff>
--- a/web-presentation/pdf-exports/ETRA-Presentation-Blank-Template.pptx
+++ b/web-presentation/pdf-exports/ETRA-Presentation-Blank-Template.pptx
@@ -3089,7 +3089,7 @@
     <p:bg>
       <p:bgPr>
         <a:solidFill>
-          <a:srgbClr val="0A0614"/>
+          <a:srgbClr val="FAF8FF"/>
         </a:solidFill>
         <a:effectLst/>
       </p:bgPr>
@@ -3103,20 +3103,20 @@
       <p:grpSpPr/>
       <p:sp>
         <p:nvSpPr>
-          <p:cNvPr id="2" name="Oval 1"/>
+          <p:cNvPr id="2" name="Rectangle 1"/>
           <p:cNvSpPr/>
           <p:nvPr/>
         </p:nvSpPr>
         <p:spPr>
           <a:xfrm>
-            <a:off x="3200400" y="731520"/>
-            <a:ext cx="5943600" cy="5029200"/>
-          </a:xfrm>
-          <a:prstGeom prst="ellipse">
+            <a:off x="12136831" y="0"/>
+            <a:ext cx="54864" cy="6858000"/>
+          </a:xfrm>
+          <a:prstGeom prst="rect">
             <a:avLst/>
           </a:prstGeom>
           <a:solidFill>
-            <a:srgbClr val="2A1860"/>
+            <a:srgbClr val="5234B7"/>
           </a:solidFill>
           <a:ln>
             <a:noFill/>
@@ -3232,7 +3232,7 @@
             <a:r>
               <a:rPr sz="4400" b="1">
                 <a:solidFill>
-                  <a:srgbClr val="FFFFFF"/>
+                  <a:srgbClr val="5234B7"/>
                 </a:solidFill>
                 <a:latin typeface="DIN Next LT W23"/>
                 <a:ea typeface="DIN Next LT W23"/>
@@ -3321,7 +3321,7 @@
             <a:r>
               <a:rPr sz="1700" b="0">
                 <a:solidFill>
-                  <a:srgbClr val="EEE8FA"/>
+                  <a:srgbClr val="5A5470"/>
                 </a:solidFill>
                 <a:latin typeface="DIN Next LT W23"/>
                 <a:ea typeface="DIN Next LT W23"/>
@@ -3358,7 +3358,7 @@
             <a:r>
               <a:rPr sz="1200" b="1">
                 <a:solidFill>
-                  <a:srgbClr val="9E59CD"/>
+                  <a:srgbClr val="5234B7"/>
                 </a:solidFill>
                 <a:latin typeface="DIN Next LT W23"/>
                 <a:ea typeface="DIN Next LT W23"/>
@@ -5682,7 +5682,7 @@
     <p:bg>
       <p:bgPr>
         <a:solidFill>
-          <a:srgbClr val="0A0614"/>
+          <a:srgbClr val="FAF8FF"/>
         </a:solidFill>
         <a:effectLst/>
       </p:bgPr>
@@ -5696,20 +5696,20 @@
       <p:grpSpPr/>
       <p:sp>
         <p:nvSpPr>
-          <p:cNvPr id="2" name="Oval 1"/>
+          <p:cNvPr id="2" name="Rectangle 1"/>
           <p:cNvSpPr/>
           <p:nvPr/>
         </p:nvSpPr>
         <p:spPr>
           <a:xfrm>
-            <a:off x="3200400" y="731520"/>
-            <a:ext cx="5943600" cy="5029200"/>
-          </a:xfrm>
-          <a:prstGeom prst="ellipse">
+            <a:off x="12136831" y="0"/>
+            <a:ext cx="54864" cy="6858000"/>
+          </a:xfrm>
+          <a:prstGeom prst="rect">
             <a:avLst/>
           </a:prstGeom>
           <a:solidFill>
-            <a:srgbClr val="2A1860"/>
+            <a:srgbClr val="5234B7"/>
           </a:solidFill>
           <a:ln>
             <a:noFill/>
@@ -5788,7 +5788,7 @@
             <a:r>
               <a:rPr sz="4000" b="1">
                 <a:solidFill>
-                  <a:srgbClr val="FFFFFF"/>
+                  <a:srgbClr val="5234B7"/>
                 </a:solidFill>
                 <a:latin typeface="DIN Next LT W23"/>
                 <a:ea typeface="DIN Next LT W23"/>
@@ -5838,14 +5838,58 @@
       </p:sp>
       <p:sp>
         <p:nvSpPr>
-          <p:cNvPr id="6" name="TextBox 5"/>
+          <p:cNvPr id="6" name="Rectangle 5"/>
+          <p:cNvSpPr/>
+          <p:nvPr/>
+        </p:nvSpPr>
+        <p:spPr>
+          <a:xfrm>
+            <a:off x="548640" y="6446520"/>
+            <a:ext cx="11064240" cy="10972"/>
+          </a:xfrm>
+          <a:prstGeom prst="rect">
+            <a:avLst/>
+          </a:prstGeom>
+          <a:solidFill>
+            <a:srgbClr val="5234B7"/>
+          </a:solidFill>
+          <a:ln>
+            <a:noFill/>
+          </a:ln>
+          <a:effectLst/>
+        </p:spPr>
+        <p:style>
+          <a:lnRef idx="1">
+            <a:schemeClr val="accent1"/>
+          </a:lnRef>
+          <a:fillRef idx="3">
+            <a:schemeClr val="accent1"/>
+          </a:fillRef>
+          <a:effectRef idx="2">
+            <a:schemeClr val="accent1"/>
+          </a:effectRef>
+          <a:fontRef idx="minor">
+            <a:schemeClr val="lt1"/>
+          </a:fontRef>
+        </p:style>
+        <p:txBody>
+          <a:bodyPr rtlCol="0" anchor="ctr"/>
+          <a:lstStyle/>
+          <a:p>
+            <a:pPr algn="ctr"/>
+          </a:p>
+        </p:txBody>
+      </p:sp>
+      <p:sp>
+        <p:nvSpPr>
+          <p:cNvPr id="7" name="TextBox 6"/>
           <p:cNvSpPr txBox="1"/>
           <p:nvPr/>
         </p:nvSpPr>
         <p:spPr>
           <a:xfrm>
-            <a:off x="548640" y="6126480"/>
-            <a:ext cx="3657600" cy="274320"/>
+            <a:off x="548640" y="6510528"/>
+            <a:ext cx="2743200" cy="256032"/>
           </a:xfrm>
           <a:prstGeom prst="rect">
             <a:avLst/>
@@ -5860,15 +5904,52 @@
           <a:p>
             <a:pPr algn="l"/>
             <a:r>
-              <a:rPr sz="1200" b="1">
-                <a:solidFill>
-                  <a:srgbClr val="9E59CD"/>
+              <a:rPr sz="1100" b="1">
+                <a:solidFill>
+                  <a:srgbClr val="5234B7"/>
                 </a:solidFill>
                 <a:latin typeface="DIN Next LT W23"/>
                 <a:ea typeface="DIN Next LT W23"/>
                 <a:cs typeface="DIN Next LT W23"/>
               </a:rPr>
               <a:t>ETRA</a:t>
+            </a:r>
+          </a:p>
+        </p:txBody>
+      </p:sp>
+      <p:sp>
+        <p:nvSpPr>
+          <p:cNvPr id="8" name="TextBox 7"/>
+          <p:cNvSpPr txBox="1"/>
+          <p:nvPr/>
+        </p:nvSpPr>
+        <p:spPr>
+          <a:xfrm>
+            <a:off x="9601200" y="6510528"/>
+            <a:ext cx="2011680" cy="256032"/>
+          </a:xfrm>
+          <a:prstGeom prst="rect">
+            <a:avLst/>
+          </a:prstGeom>
+          <a:noFill/>
+        </p:spPr>
+        <p:txBody>
+          <a:bodyPr wrap="square" anchor="t">
+            <a:spAutoFit/>
+          </a:bodyPr>
+          <a:lstStyle/>
+          <a:p>
+            <a:pPr algn="r"/>
+            <a:r>
+              <a:rPr sz="1100" b="0">
+                <a:solidFill>
+                  <a:srgbClr val="5A5470"/>
+                </a:solidFill>
+                <a:latin typeface="DIN Next LT W23"/>
+                <a:ea typeface="DIN Next LT W23"/>
+                <a:cs typeface="DIN Next LT W23"/>
+              </a:rPr>
+              <a:t>06  /  06</a:t>
             </a:r>
           </a:p>
         </p:txBody>

</xml_diff>